<commit_message>
fix: harden competition release readiness
</commit_message>
<xml_diff>
--- a/docs/competition/AgentRig-GOAI-2026-初赛方案.pptx
+++ b/docs/competition/AgentRig-GOAI-2026-初赛方案.pptx
@@ -5425,7 +5425,7 @@
                 </a:solidFill>
                 <a:latin typeface="IBM Plex Mono"/>
               </a:rPr>
-              <a:t>10</a:t>
+              <a:t>11</a:t>
             </a:r>
           </a:p>
         </p:txBody>
@@ -14848,7 +14848,7 @@
                 </a:solidFill>
                 <a:latin typeface="PingFang SC"/>
               </a:rPr>
-              <a:t>10 个 Skill + 三套最小权限 MCP 工具集</a:t>
+              <a:t>11 个 Skill + 三套最小权限 MCP 工具集</a:t>
             </a:r>
           </a:p>
         </p:txBody>
@@ -15020,7 +15020,7 @@
                 </a:solidFill>
                 <a:latin typeface="IBM Plex Mono"/>
               </a:rPr>
-              <a:t>MANAGER / 5</a:t>
+              <a:t>MANAGER / 6</a:t>
             </a:r>
           </a:p>
         </p:txBody>
@@ -15149,7 +15149,7 @@
                 </a:solidFill>
                 <a:latin typeface="IBM Plex Mono"/>
               </a:rPr>
-              <a:t>plan-evaluation</a:t>
+              <a:t>adaptive-evaluation</a:t>
             </a:r>
           </a:p>
         </p:txBody>
@@ -15278,7 +15278,7 @@
                 </a:solidFill>
                 <a:latin typeface="IBM Plex Mono"/>
               </a:rPr>
-              <a:t>execute-evaluation-plan</a:t>
+              <a:t>plan-evaluation</a:t>
             </a:r>
           </a:p>
         </p:txBody>
@@ -15407,7 +15407,7 @@
                 </a:solidFill>
                 <a:latin typeface="IBM Plex Mono"/>
               </a:rPr>
-              <a:t>diagnose-run</a:t>
+              <a:t>execute-evaluation-plan</a:t>
             </a:r>
           </a:p>
         </p:txBody>
@@ -15536,7 +15536,7 @@
                 </a:solidFill>
                 <a:latin typeface="IBM Plex Mono"/>
               </a:rPr>
-              <a:t>build-test-case-draft</a:t>
+              <a:t>diagnose-run</a:t>
             </a:r>
           </a:p>
         </p:txBody>
@@ -15665,6 +15665,135 @@
                 </a:solidFill>
                 <a:latin typeface="IBM Plex Mono"/>
               </a:rPr>
+              <a:t>build-test-case-draft</a:t>
+            </a:r>
+          </a:p>
+        </p:txBody>
+      </p:sp>
+      <p:sp>
+        <p:nvSpPr>
+          <p:cNvPr id="25" name="Rectangle 24"/>
+          <p:cNvSpPr/>
+          <p:nvPr/>
+        </p:nvSpPr>
+        <p:spPr>
+          <a:xfrm>
+            <a:off x="822959" y="5138928"/>
+            <a:ext cx="3246120" cy="365760"/>
+          </a:xfrm>
+          <a:prstGeom prst="rect">
+            <a:avLst/>
+          </a:prstGeom>
+          <a:solidFill>
+            <a:srgbClr val="F7F8F7"/>
+          </a:solidFill>
+          <a:ln w="8890">
+            <a:solidFill>
+              <a:srgbClr val="D7DDD9"/>
+            </a:solidFill>
+          </a:ln>
+        </p:spPr>
+        <p:style>
+          <a:lnRef idx="1">
+            <a:schemeClr val="accent1"/>
+          </a:lnRef>
+          <a:fillRef idx="3">
+            <a:schemeClr val="accent1"/>
+          </a:fillRef>
+          <a:effectRef idx="2">
+            <a:schemeClr val="accent1"/>
+          </a:effectRef>
+          <a:fontRef idx="minor">
+            <a:schemeClr val="lt1"/>
+          </a:fontRef>
+        </p:style>
+        <p:txBody>
+          <a:bodyPr rtlCol="0" anchor="ctr"/>
+          <a:lstStyle/>
+          <a:p>
+            <a:pPr algn="ctr"/>
+          </a:p>
+        </p:txBody>
+      </p:sp>
+      <p:sp>
+        <p:nvSpPr>
+          <p:cNvPr id="26" name="TextBox 25"/>
+          <p:cNvSpPr txBox="1"/>
+          <p:nvPr/>
+        </p:nvSpPr>
+        <p:spPr>
+          <a:xfrm>
+            <a:off x="950976" y="5248656"/>
+            <a:ext cx="292608" cy="137160"/>
+          </a:xfrm>
+          <a:prstGeom prst="rect">
+            <a:avLst/>
+          </a:prstGeom>
+          <a:noFill/>
+        </p:spPr>
+        <p:txBody>
+          <a:bodyPr wrap="none" lIns="0" rIns="0" tIns="0" bIns="0" anchor="t">
+            <a:spAutoFit/>
+          </a:bodyPr>
+          <a:lstStyle/>
+          <a:p>
+            <a:pPr algn="l">
+              <a:lnSpc>
+                <a:spcPct val="108000"/>
+              </a:lnSpc>
+              <a:spcAft>
+                <a:spcPts val="0"/>
+              </a:spcAft>
+            </a:pPr>
+            <a:r>
+              <a:rPr sz="650" b="0">
+                <a:solidFill>
+                  <a:srgbClr val="737B77"/>
+                </a:solidFill>
+                <a:latin typeface="IBM Plex Mono"/>
+              </a:rPr>
+              <a:t>06</a:t>
+            </a:r>
+          </a:p>
+        </p:txBody>
+      </p:sp>
+      <p:sp>
+        <p:nvSpPr>
+          <p:cNvPr id="27" name="TextBox 26"/>
+          <p:cNvSpPr txBox="1"/>
+          <p:nvPr/>
+        </p:nvSpPr>
+        <p:spPr>
+          <a:xfrm>
+            <a:off x="1298448" y="5221224"/>
+            <a:ext cx="2606040" cy="182880"/>
+          </a:xfrm>
+          <a:prstGeom prst="rect">
+            <a:avLst/>
+          </a:prstGeom>
+          <a:noFill/>
+        </p:spPr>
+        <p:txBody>
+          <a:bodyPr wrap="none" lIns="0" rIns="0" tIns="0" bIns="0" anchor="t">
+            <a:spAutoFit/>
+          </a:bodyPr>
+          <a:lstStyle/>
+          <a:p>
+            <a:pPr algn="l">
+              <a:lnSpc>
+                <a:spcPct val="108000"/>
+              </a:lnSpc>
+              <a:spcAft>
+                <a:spcPts val="0"/>
+              </a:spcAft>
+            </a:pPr>
+            <a:r>
+              <a:rPr sz="850" b="1">
+                <a:solidFill>
+                  <a:srgbClr val="252927"/>
+                </a:solidFill>
+                <a:latin typeface="IBM Plex Mono"/>
+              </a:rPr>
               <a:t>configure-test-target</a:t>
             </a:r>
           </a:p>
@@ -15672,7 +15801,7 @@
       </p:sp>
       <p:sp>
         <p:nvSpPr>
-          <p:cNvPr id="25" name="Rectangle 24"/>
+          <p:cNvPr id="28" name="Rectangle 27"/>
           <p:cNvSpPr/>
           <p:nvPr/>
         </p:nvSpPr>
@@ -15717,7 +15846,7 @@
       </p:sp>
       <p:sp>
         <p:nvSpPr>
-          <p:cNvPr id="26" name="TextBox 25"/>
+          <p:cNvPr id="29" name="TextBox 28"/>
           <p:cNvSpPr txBox="1"/>
           <p:nvPr/>
         </p:nvSpPr>
@@ -15759,7 +15888,7 @@
       </p:sp>
       <p:sp>
         <p:nvSpPr>
-          <p:cNvPr id="27" name="Rectangle 26"/>
+          <p:cNvPr id="30" name="Rectangle 29"/>
           <p:cNvSpPr/>
           <p:nvPr/>
         </p:nvSpPr>
@@ -15804,7 +15933,7 @@
       </p:sp>
       <p:sp>
         <p:nvSpPr>
-          <p:cNvPr id="28" name="TextBox 27"/>
+          <p:cNvPr id="31" name="TextBox 30"/>
           <p:cNvSpPr txBox="1"/>
           <p:nvPr/>
         </p:nvSpPr>
@@ -15846,7 +15975,7 @@
       </p:sp>
       <p:sp>
         <p:nvSpPr>
-          <p:cNvPr id="29" name="TextBox 28"/>
+          <p:cNvPr id="32" name="TextBox 31"/>
           <p:cNvSpPr txBox="1"/>
           <p:nvPr/>
         </p:nvSpPr>
@@ -15888,7 +16017,7 @@
       </p:sp>
       <p:sp>
         <p:nvSpPr>
-          <p:cNvPr id="30" name="Rectangle 29"/>
+          <p:cNvPr id="33" name="Rectangle 32"/>
           <p:cNvSpPr/>
           <p:nvPr/>
         </p:nvSpPr>
@@ -15933,7 +16062,7 @@
       </p:sp>
       <p:sp>
         <p:nvSpPr>
-          <p:cNvPr id="31" name="TextBox 30"/>
+          <p:cNvPr id="34" name="TextBox 33"/>
           <p:cNvSpPr txBox="1"/>
           <p:nvPr/>
         </p:nvSpPr>
@@ -15975,7 +16104,7 @@
       </p:sp>
       <p:sp>
         <p:nvSpPr>
-          <p:cNvPr id="32" name="TextBox 31"/>
+          <p:cNvPr id="35" name="TextBox 34"/>
           <p:cNvSpPr txBox="1"/>
           <p:nvPr/>
         </p:nvSpPr>
@@ -16017,7 +16146,7 @@
       </p:sp>
       <p:sp>
         <p:nvSpPr>
-          <p:cNvPr id="33" name="Rectangle 32"/>
+          <p:cNvPr id="36" name="Rectangle 35"/>
           <p:cNvSpPr/>
           <p:nvPr/>
         </p:nvSpPr>
@@ -16062,7 +16191,7 @@
       </p:sp>
       <p:sp>
         <p:nvSpPr>
-          <p:cNvPr id="34" name="TextBox 33"/>
+          <p:cNvPr id="37" name="TextBox 36"/>
           <p:cNvSpPr txBox="1"/>
           <p:nvPr/>
         </p:nvSpPr>
@@ -16104,7 +16233,7 @@
       </p:sp>
       <p:sp>
         <p:nvSpPr>
-          <p:cNvPr id="35" name="Rectangle 34"/>
+          <p:cNvPr id="38" name="Rectangle 37"/>
           <p:cNvSpPr/>
           <p:nvPr/>
         </p:nvSpPr>
@@ -16149,7 +16278,7 @@
       </p:sp>
       <p:sp>
         <p:nvSpPr>
-          <p:cNvPr id="36" name="TextBox 35"/>
+          <p:cNvPr id="39" name="TextBox 38"/>
           <p:cNvSpPr txBox="1"/>
           <p:nvPr/>
         </p:nvSpPr>
@@ -16191,7 +16320,7 @@
       </p:sp>
       <p:sp>
         <p:nvSpPr>
-          <p:cNvPr id="37" name="TextBox 36"/>
+          <p:cNvPr id="40" name="TextBox 39"/>
           <p:cNvSpPr txBox="1"/>
           <p:nvPr/>
         </p:nvSpPr>
@@ -16226,14 +16355,14 @@
                 </a:solidFill>
                 <a:latin typeface="IBM Plex Mono"/>
               </a:rPr>
-              <a:t>run-evaluations</a:t>
-            </a:r>
-          </a:p>
-        </p:txBody>
-      </p:sp>
-      <p:sp>
-        <p:nvSpPr>
-          <p:cNvPr id="38" name="Rectangle 37"/>
+              <a:t>run-test-cases</a:t>
+            </a:r>
+          </a:p>
+        </p:txBody>
+      </p:sp>
+      <p:sp>
+        <p:nvSpPr>
+          <p:cNvPr id="41" name="Rectangle 40"/>
           <p:cNvSpPr/>
           <p:nvPr/>
         </p:nvSpPr>
@@ -16278,7 +16407,7 @@
       </p:sp>
       <p:sp>
         <p:nvSpPr>
-          <p:cNvPr id="39" name="TextBox 38"/>
+          <p:cNvPr id="42" name="TextBox 41"/>
           <p:cNvSpPr txBox="1"/>
           <p:nvPr/>
         </p:nvSpPr>
@@ -16320,7 +16449,7 @@
       </p:sp>
       <p:sp>
         <p:nvSpPr>
-          <p:cNvPr id="40" name="TextBox 39"/>
+          <p:cNvPr id="43" name="TextBox 42"/>
           <p:cNvSpPr txBox="1"/>
           <p:nvPr/>
         </p:nvSpPr>
@@ -16355,14 +16484,14 @@
                 </a:solidFill>
                 <a:latin typeface="IBM Plex Mono"/>
               </a:rPr>
-              <a:t>build-test-cases</a:t>
-            </a:r>
-          </a:p>
-        </p:txBody>
-      </p:sp>
-      <p:sp>
-        <p:nvSpPr>
-          <p:cNvPr id="41" name="Rectangle 40"/>
+              <a:t>build-test-case</a:t>
+            </a:r>
+          </a:p>
+        </p:txBody>
+      </p:sp>
+      <p:sp>
+        <p:nvSpPr>
+          <p:cNvPr id="44" name="Rectangle 43"/>
           <p:cNvSpPr/>
           <p:nvPr/>
         </p:nvSpPr>
@@ -16407,7 +16536,7 @@
       </p:sp>
       <p:sp>
         <p:nvSpPr>
-          <p:cNvPr id="42" name="TextBox 41"/>
+          <p:cNvPr id="45" name="TextBox 44"/>
           <p:cNvSpPr txBox="1"/>
           <p:nvPr/>
         </p:nvSpPr>
@@ -16449,7 +16578,7 @@
       </p:sp>
       <p:sp>
         <p:nvSpPr>
-          <p:cNvPr id="43" name="TextBox 42"/>
+          <p:cNvPr id="46" name="TextBox 45"/>
           <p:cNvSpPr txBox="1"/>
           <p:nvPr/>
         </p:nvSpPr>
@@ -16484,14 +16613,14 @@
                 </a:solidFill>
                 <a:latin typeface="IBM Plex Mono"/>
               </a:rPr>
-              <a:t>collect-tool-samples</a:t>
-            </a:r>
-          </a:p>
-        </p:txBody>
-      </p:sp>
-      <p:sp>
-        <p:nvSpPr>
-          <p:cNvPr id="44" name="TextBox 43"/>
+              <a:t>harvest-tool-samples</a:t>
+            </a:r>
+          </a:p>
+        </p:txBody>
+      </p:sp>
+      <p:sp>
+        <p:nvSpPr>
+          <p:cNvPr id="47" name="TextBox 46"/>
           <p:cNvSpPr txBox="1"/>
           <p:nvPr/>
         </p:nvSpPr>

</xml_diff>

<commit_message>
feat: showcase the skill design, PI archive, and real Codex TUI session
- Rerun the Codex CLI governance session against the localized Chinese
  skill: run_33efe834… (5/5, same frozen manifest) with disciplined
  preview -> expected_manifest_hash -> poll -> per-attempt event checks,
  and an honest PARTIAL for the headline-only scope.
- Re-render both Codex captures in the authentic TUI style (banner,
  prompt strip, mcp lines, footer) from the real transcript.
- Slide 8 now carries the PI iteration-archive visual (real
  docs/prompt-iterations content); slide 15 shows the sanitized lassist
  skill inventory proving day-to-day engineering usage.
- Sync the confirmation run id and archive/skill narration across the
  evidence report, ledger JSONs, index, doc 13, and video scenes.

Co-Authored-By: Claude Fable 5 <noreply@anthropic.com>
</commit_message>
<xml_diff>
--- a/docs/competition/AgentRig-GOAI-2026-初赛方案.pptx
+++ b/docs/competition/AgentRig-GOAI-2026-初赛方案.pptx
@@ -10576,8 +10576,8 @@
         </p:nvSpPr>
         <p:spPr>
           <a:xfrm>
-            <a:off x="713232" y="1865376"/>
-            <a:ext cx="3401568" cy="3566160"/>
+            <a:off x="694944" y="1847088"/>
+            <a:ext cx="6757416" cy="3621024"/>
           </a:xfrm>
           <a:prstGeom prst="rect">
             <a:avLst/>
@@ -10613,223 +10613,82 @@
           </a:p>
         </p:txBody>
       </p:sp>
-      <p:sp>
-        <p:nvSpPr>
-          <p:cNvPr id="10" name="Rectangle 9"/>
+      <p:pic>
+        <p:nvPicPr>
+          <p:cNvPr id="10" name="Picture 9" descr="skill-ecosystem.png"/>
+          <p:cNvPicPr>
+            <a:picLocks noChangeAspect="1"/>
+          </p:cNvPicPr>
+          <p:nvPr/>
+        </p:nvPicPr>
+        <p:blipFill>
+          <a:blip r:embed="rId2"/>
+          <a:stretch>
+            <a:fillRect/>
+          </a:stretch>
+        </p:blipFill>
+        <p:spPr>
+          <a:xfrm>
+            <a:off x="713232" y="1865376"/>
+            <a:ext cx="6720840" cy="3584448"/>
+          </a:xfrm>
+          <a:prstGeom prst="rect">
+            <a:avLst/>
+          </a:prstGeom>
+        </p:spPr>
+      </p:pic>
+      <p:sp>
+        <p:nvSpPr>
+          <p:cNvPr id="11" name="TextBox 10"/>
+          <p:cNvSpPr txBox="1"/>
+          <p:nvPr/>
+        </p:nvSpPr>
+        <p:spPr>
+          <a:xfrm>
+            <a:off x="713232" y="5559552"/>
+            <a:ext cx="6675120" cy="219456"/>
+          </a:xfrm>
+          <a:prstGeom prst="rect">
+            <a:avLst/>
+          </a:prstGeom>
+          <a:noFill/>
+        </p:spPr>
+        <p:txBody>
+          <a:bodyPr wrap="square" lIns="0" rIns="0" tIns="0" bIns="0" anchor="t">
+            <a:spAutoFit/>
+          </a:bodyPr>
+          <a:lstStyle/>
+          <a:p>
+            <a:pPr algn="l">
+              <a:lnSpc>
+                <a:spcPct val="108000"/>
+              </a:lnSpc>
+              <a:spcAft>
+                <a:spcPts val="0"/>
+              </a:spcAft>
+            </a:pPr>
+            <a:r>
+              <a:rPr sz="919" b="0">
+                <a:solidFill>
+                  <a:srgbClr val="67706B"/>
+                </a:solidFill>
+                <a:latin typeface="Menlo"/>
+              </a:rPr>
+              <a:t>真实工程 Skill 生态（lassist · 已脱敏）</a:t>
+            </a:r>
+          </a:p>
+        </p:txBody>
+      </p:sp>
+      <p:sp>
+        <p:nvSpPr>
+          <p:cNvPr id="12" name="Rectangle 11"/>
           <p:cNvSpPr/>
           <p:nvPr/>
         </p:nvSpPr>
         <p:spPr>
           <a:xfrm>
-            <a:off x="987552" y="2130552"/>
-            <a:ext cx="457200" cy="329184"/>
-          </a:xfrm>
-          <a:prstGeom prst="rect">
-            <a:avLst/>
-          </a:prstGeom>
-          <a:solidFill>
-            <a:srgbClr val="E9EFFF"/>
-          </a:solidFill>
-          <a:ln>
-            <a:noFill/>
-          </a:ln>
-        </p:spPr>
-        <p:style>
-          <a:lnRef idx="1">
-            <a:schemeClr val="accent1"/>
-          </a:lnRef>
-          <a:fillRef idx="3">
-            <a:schemeClr val="accent1"/>
-          </a:fillRef>
-          <a:effectRef idx="2">
-            <a:schemeClr val="accent1"/>
-          </a:effectRef>
-          <a:fontRef idx="minor">
-            <a:schemeClr val="lt1"/>
-          </a:fontRef>
-        </p:style>
-        <p:txBody>
-          <a:bodyPr rtlCol="0" anchor="ctr"/>
-          <a:lstStyle/>
-          <a:p>
-            <a:pPr algn="ctr"/>
-          </a:p>
-        </p:txBody>
-      </p:sp>
-      <p:sp>
-        <p:nvSpPr>
-          <p:cNvPr id="11" name="TextBox 10"/>
-          <p:cNvSpPr txBox="1"/>
-          <p:nvPr/>
-        </p:nvSpPr>
-        <p:spPr>
-          <a:xfrm>
-            <a:off x="987552" y="2130552"/>
-            <a:ext cx="457200" cy="329184"/>
-          </a:xfrm>
-          <a:prstGeom prst="rect">
-            <a:avLst/>
-          </a:prstGeom>
-          <a:noFill/>
-        </p:spPr>
-        <p:txBody>
-          <a:bodyPr wrap="square" lIns="0" rIns="0" tIns="0" bIns="0" anchor="ctr">
-            <a:spAutoFit/>
-          </a:bodyPr>
-          <a:lstStyle/>
-          <a:p>
-            <a:pPr algn="ctr">
-              <a:lnSpc>
-                <a:spcPct val="108000"/>
-              </a:lnSpc>
-              <a:spcAft>
-                <a:spcPts val="0"/>
-              </a:spcAft>
-            </a:pPr>
-            <a:r>
-              <a:rPr sz="840" b="1">
-                <a:solidFill>
-                  <a:srgbClr val="285CF5"/>
-                </a:solidFill>
-                <a:latin typeface="PingFang SC"/>
-              </a:rPr>
-              <a:t>01</a:t>
-            </a:r>
-          </a:p>
-        </p:txBody>
-      </p:sp>
-      <p:sp>
-        <p:nvSpPr>
-          <p:cNvPr id="12" name="TextBox 11"/>
-          <p:cNvSpPr txBox="1"/>
-          <p:nvPr/>
-        </p:nvSpPr>
-        <p:spPr>
-          <a:xfrm>
-            <a:off x="987552" y="2706624"/>
-            <a:ext cx="2788920" cy="320040"/>
-          </a:xfrm>
-          <a:prstGeom prst="rect">
-            <a:avLst/>
-          </a:prstGeom>
-          <a:noFill/>
-        </p:spPr>
-        <p:txBody>
-          <a:bodyPr wrap="square" lIns="0" rIns="0" tIns="0" bIns="0" anchor="t">
-            <a:spAutoFit/>
-          </a:bodyPr>
-          <a:lstStyle/>
-          <a:p>
-            <a:pPr algn="l">
-              <a:lnSpc>
-                <a:spcPct val="108000"/>
-              </a:lnSpc>
-              <a:spcAft>
-                <a:spcPts val="0"/>
-              </a:spcAft>
-            </a:pPr>
-            <a:r>
-              <a:rPr sz="1700" b="1">
-                <a:solidFill>
-                  <a:srgbClr val="121617"/>
-                </a:solidFill>
-                <a:latin typeface="PingFang SC"/>
-              </a:rPr>
-              <a:t>AgentScope 实践</a:t>
-            </a:r>
-          </a:p>
-        </p:txBody>
-      </p:sp>
-      <p:sp>
-        <p:nvSpPr>
-          <p:cNvPr id="13" name="TextBox 12"/>
-          <p:cNvSpPr txBox="1"/>
-          <p:nvPr/>
-        </p:nvSpPr>
-        <p:spPr>
-          <a:xfrm>
-            <a:off x="987552" y="3346704"/>
-            <a:ext cx="2761488" cy="1316736"/>
-          </a:xfrm>
-          <a:prstGeom prst="rect">
-            <a:avLst/>
-          </a:prstGeom>
-          <a:noFill/>
-        </p:spPr>
-        <p:txBody>
-          <a:bodyPr wrap="square" lIns="0" rIns="0" tIns="0" bIns="0">
-            <a:spAutoFit/>
-          </a:bodyPr>
-          <a:lstStyle/>
-          <a:p>
-            <a:pPr>
-              <a:lnSpc>
-                <a:spcPct val="115000"/>
-              </a:lnSpc>
-              <a:spcAft>
-                <a:spcPts val="1000"/>
-              </a:spcAft>
-              <a:defRPr sz="1100">
-                <a:solidFill>
-                  <a:srgbClr val="67706B"/>
-                </a:solidFill>
-                <a:latin typeface="PingFang SC"/>
-              </a:defRPr>
-            </a:pPr>
-            <a:r>
-              <a:t>•  真实业务评测闭环</a:t>
-            </a:r>
-          </a:p>
-          <a:p>
-            <a:pPr>
-              <a:lnSpc>
-                <a:spcPct val="115000"/>
-              </a:lnSpc>
-              <a:spcAft>
-                <a:spcPts val="1000"/>
-              </a:spcAft>
-              <a:defRPr sz="1100">
-                <a:solidFill>
-                  <a:srgbClr val="67706B"/>
-                </a:solidFill>
-                <a:latin typeface="PingFang SC"/>
-              </a:defRPr>
-            </a:pPr>
-            <a:r>
-              <a:t>•  工作台交互经验</a:t>
-            </a:r>
-          </a:p>
-          <a:p>
-            <a:pPr>
-              <a:lnSpc>
-                <a:spcPct val="115000"/>
-              </a:lnSpc>
-              <a:spcAft>
-                <a:spcPts val="1000"/>
-              </a:spcAft>
-              <a:defRPr sz="1100">
-                <a:solidFill>
-                  <a:srgbClr val="67706B"/>
-                </a:solidFill>
-                <a:latin typeface="PingFang SC"/>
-              </a:defRPr>
-            </a:pPr>
-            <a:r>
-              <a:t>•  AgentTeams 协作范式</a:t>
-            </a:r>
-          </a:p>
-        </p:txBody>
-      </p:sp>
-      <p:sp>
-        <p:nvSpPr>
-          <p:cNvPr id="14" name="Rectangle 13"/>
-          <p:cNvSpPr/>
-          <p:nvPr/>
-        </p:nvSpPr>
-        <p:spPr>
-          <a:xfrm>
-            <a:off x="4489704" y="1865376"/>
-            <a:ext cx="3401568" cy="3566160"/>
+            <a:off x="7680960" y="1865376"/>
+            <a:ext cx="3794760" cy="1097280"/>
           </a:xfrm>
           <a:prstGeom prst="rect">
             <a:avLst/>
@@ -10867,20 +10726,20 @@
       </p:sp>
       <p:sp>
         <p:nvSpPr>
-          <p:cNvPr id="15" name="Rectangle 14"/>
+          <p:cNvPr id="13" name="Rectangle 12"/>
           <p:cNvSpPr/>
           <p:nvPr/>
         </p:nvSpPr>
         <p:spPr>
           <a:xfrm>
-            <a:off x="4764024" y="2130552"/>
+            <a:off x="7882127" y="2011680"/>
             <a:ext cx="457200" cy="329184"/>
           </a:xfrm>
           <a:prstGeom prst="rect">
             <a:avLst/>
           </a:prstGeom>
           <a:solidFill>
-            <a:srgbClr val="E7F3EE"/>
+            <a:srgbClr val="E9EFFF"/>
           </a:solidFill>
           <a:ln>
             <a:noFill/>
@@ -10910,178 +10769,140 @@
       </p:sp>
       <p:sp>
         <p:nvSpPr>
+          <p:cNvPr id="14" name="TextBox 13"/>
+          <p:cNvSpPr txBox="1"/>
+          <p:nvPr/>
+        </p:nvSpPr>
+        <p:spPr>
+          <a:xfrm>
+            <a:off x="7882127" y="2011680"/>
+            <a:ext cx="457200" cy="329184"/>
+          </a:xfrm>
+          <a:prstGeom prst="rect">
+            <a:avLst/>
+          </a:prstGeom>
+          <a:noFill/>
+        </p:spPr>
+        <p:txBody>
+          <a:bodyPr wrap="square" lIns="0" rIns="0" tIns="0" bIns="0" anchor="ctr">
+            <a:spAutoFit/>
+          </a:bodyPr>
+          <a:lstStyle/>
+          <a:p>
+            <a:pPr algn="ctr">
+              <a:lnSpc>
+                <a:spcPct val="108000"/>
+              </a:lnSpc>
+              <a:spcAft>
+                <a:spcPts val="0"/>
+              </a:spcAft>
+            </a:pPr>
+            <a:r>
+              <a:rPr sz="840" b="1">
+                <a:solidFill>
+                  <a:srgbClr val="285CF5"/>
+                </a:solidFill>
+                <a:latin typeface="PingFang SC"/>
+              </a:rPr>
+              <a:t>01</a:t>
+            </a:r>
+          </a:p>
+        </p:txBody>
+      </p:sp>
+      <p:sp>
+        <p:nvSpPr>
+          <p:cNvPr id="15" name="TextBox 14"/>
+          <p:cNvSpPr txBox="1"/>
+          <p:nvPr/>
+        </p:nvSpPr>
+        <p:spPr>
+          <a:xfrm>
+            <a:off x="8503920" y="1993392"/>
+            <a:ext cx="2926080" cy="256032"/>
+          </a:xfrm>
+          <a:prstGeom prst="rect">
+            <a:avLst/>
+          </a:prstGeom>
+          <a:noFill/>
+        </p:spPr>
+        <p:txBody>
+          <a:bodyPr wrap="square" lIns="0" rIns="0" tIns="0" bIns="0" anchor="t">
+            <a:spAutoFit/>
+          </a:bodyPr>
+          <a:lstStyle/>
+          <a:p>
+            <a:pPr algn="l">
+              <a:lnSpc>
+                <a:spcPct val="108000"/>
+              </a:lnSpc>
+              <a:spcAft>
+                <a:spcPts val="0"/>
+              </a:spcAft>
+            </a:pPr>
+            <a:r>
+              <a:rPr sz="1300" b="1">
+                <a:solidFill>
+                  <a:srgbClr val="121617"/>
+                </a:solidFill>
+                <a:latin typeface="PingFang SC"/>
+              </a:rPr>
+              <a:t>AgentScope 实践</a:t>
+            </a:r>
+          </a:p>
+        </p:txBody>
+      </p:sp>
+      <p:sp>
+        <p:nvSpPr>
           <p:cNvPr id="16" name="TextBox 15"/>
           <p:cNvSpPr txBox="1"/>
           <p:nvPr/>
         </p:nvSpPr>
         <p:spPr>
           <a:xfrm>
-            <a:off x="4764024" y="2130552"/>
-            <a:ext cx="457200" cy="329184"/>
-          </a:xfrm>
-          <a:prstGeom prst="rect">
-            <a:avLst/>
-          </a:prstGeom>
-          <a:noFill/>
-        </p:spPr>
-        <p:txBody>
-          <a:bodyPr wrap="square" lIns="0" rIns="0" tIns="0" bIns="0" anchor="ctr">
-            <a:spAutoFit/>
-          </a:bodyPr>
-          <a:lstStyle/>
-          <a:p>
-            <a:pPr algn="ctr">
-              <a:lnSpc>
-                <a:spcPct val="108000"/>
-              </a:lnSpc>
-              <a:spcAft>
-                <a:spcPts val="0"/>
-              </a:spcAft>
-            </a:pPr>
-            <a:r>
-              <a:rPr sz="840" b="1">
-                <a:solidFill>
-                  <a:srgbClr val="17745A"/>
-                </a:solidFill>
-                <a:latin typeface="PingFang SC"/>
-              </a:rPr>
-              <a:t>02</a:t>
-            </a:r>
-          </a:p>
-        </p:txBody>
-      </p:sp>
-      <p:sp>
-        <p:nvSpPr>
-          <p:cNvPr id="17" name="TextBox 16"/>
-          <p:cNvSpPr txBox="1"/>
-          <p:nvPr/>
-        </p:nvSpPr>
-        <p:spPr>
-          <a:xfrm>
-            <a:off x="4764024" y="2706624"/>
-            <a:ext cx="2788920" cy="320040"/>
-          </a:xfrm>
-          <a:prstGeom prst="rect">
-            <a:avLst/>
-          </a:prstGeom>
-          <a:noFill/>
-        </p:spPr>
-        <p:txBody>
-          <a:bodyPr wrap="square" lIns="0" rIns="0" tIns="0" bIns="0" anchor="t">
-            <a:spAutoFit/>
-          </a:bodyPr>
-          <a:lstStyle/>
-          <a:p>
-            <a:pPr algn="l">
-              <a:lnSpc>
-                <a:spcPct val="108000"/>
-              </a:lnSpc>
-              <a:spcAft>
-                <a:spcPts val="0"/>
-              </a:spcAft>
-            </a:pPr>
-            <a:r>
-              <a:rPr sz="1700" b="1">
-                <a:solidFill>
-                  <a:srgbClr val="121617"/>
-                </a:solidFill>
-                <a:latin typeface="PingFang SC"/>
-              </a:rPr>
-              <a:t>AgentRig 开源内核</a:t>
-            </a:r>
-          </a:p>
-        </p:txBody>
-      </p:sp>
-      <p:sp>
-        <p:nvSpPr>
-          <p:cNvPr id="18" name="TextBox 17"/>
-          <p:cNvSpPr txBox="1"/>
-          <p:nvPr/>
-        </p:nvSpPr>
-        <p:spPr>
-          <a:xfrm>
-            <a:off x="4764024" y="3346704"/>
-            <a:ext cx="2761488" cy="1316736"/>
-          </a:xfrm>
-          <a:prstGeom prst="rect">
-            <a:avLst/>
-          </a:prstGeom>
-          <a:noFill/>
-        </p:spPr>
-        <p:txBody>
-          <a:bodyPr wrap="square" lIns="0" rIns="0" tIns="0" bIns="0">
-            <a:spAutoFit/>
-          </a:bodyPr>
-          <a:lstStyle/>
-          <a:p>
-            <a:pPr>
-              <a:lnSpc>
-                <a:spcPct val="115000"/>
-              </a:lnSpc>
-              <a:spcAft>
-                <a:spcPts val="1000"/>
-              </a:spcAft>
-              <a:defRPr sz="1100">
+            <a:off x="7882127" y="2395728"/>
+            <a:ext cx="3429000" cy="502920"/>
+          </a:xfrm>
+          <a:prstGeom prst="rect">
+            <a:avLst/>
+          </a:prstGeom>
+          <a:noFill/>
+        </p:spPr>
+        <p:txBody>
+          <a:bodyPr wrap="square" lIns="0" rIns="0" tIns="0" bIns="0" anchor="t">
+            <a:spAutoFit/>
+          </a:bodyPr>
+          <a:lstStyle/>
+          <a:p>
+            <a:pPr algn="l">
+              <a:lnSpc>
+                <a:spcPct val="125000"/>
+              </a:lnSpc>
+              <a:spcAft>
+                <a:spcPts val="0"/>
+              </a:spcAft>
+            </a:pPr>
+            <a:r>
+              <a:rPr sz="880" b="0">
                 <a:solidFill>
                   <a:srgbClr val="67706B"/>
                 </a:solidFill>
                 <a:latin typeface="PingFang SC"/>
-              </a:defRPr>
-            </a:pPr>
-            <a:r>
-              <a:t>•  协议无关 Driver</a:t>
-            </a:r>
-          </a:p>
-          <a:p>
-            <a:pPr>
-              <a:lnSpc>
-                <a:spcPct val="115000"/>
-              </a:lnSpc>
-              <a:spcAft>
-                <a:spcPts val="1000"/>
-              </a:spcAft>
-              <a:defRPr sz="1100">
-                <a:solidFill>
-                  <a:srgbClr val="67706B"/>
-                </a:solidFill>
-                <a:latin typeface="PingFang SC"/>
-              </a:defRPr>
-            </a:pPr>
-            <a:r>
-              <a:t>•  低副作用 Provider</a:t>
-            </a:r>
-          </a:p>
-          <a:p>
-            <a:pPr>
-              <a:lnSpc>
-                <a:spcPct val="115000"/>
-              </a:lnSpc>
-              <a:spcAft>
-                <a:spcPts val="1000"/>
-              </a:spcAft>
-              <a:defRPr sz="1100">
-                <a:solidFill>
-                  <a:srgbClr val="67706B"/>
-                </a:solidFill>
-                <a:latin typeface="PingFang SC"/>
-              </a:defRPr>
-            </a:pPr>
-            <a:r>
-              <a:t>•  Canonical Evidence</a:t>
-            </a:r>
-          </a:p>
-        </p:txBody>
-      </p:sp>
-      <p:sp>
-        <p:nvSpPr>
-          <p:cNvPr id="19" name="Rectangle 18"/>
+              </a:rPr>
+              <a:t>真实业务评测闭环 · 11 个评测/治理 Skill 常态使用 · AgentTeams 协作范式</a:t>
+            </a:r>
+          </a:p>
+        </p:txBody>
+      </p:sp>
+      <p:sp>
+        <p:nvSpPr>
+          <p:cNvPr id="17" name="Rectangle 16"/>
           <p:cNvSpPr/>
           <p:nvPr/>
         </p:nvSpPr>
         <p:spPr>
           <a:xfrm>
-            <a:off x="8266175" y="1865376"/>
-            <a:ext cx="3401568" cy="3566160"/>
+            <a:off x="7680960" y="3090672"/>
+            <a:ext cx="3794760" cy="1097280"/>
           </a:xfrm>
           <a:prstGeom prst="rect">
             <a:avLst/>
@@ -11119,13 +10940,227 @@
       </p:sp>
       <p:sp>
         <p:nvSpPr>
-          <p:cNvPr id="20" name="Rectangle 19"/>
+          <p:cNvPr id="18" name="Rectangle 17"/>
           <p:cNvSpPr/>
           <p:nvPr/>
         </p:nvSpPr>
         <p:spPr>
           <a:xfrm>
-            <a:off x="8540496" y="2130552"/>
+            <a:off x="7882127" y="3236976"/>
+            <a:ext cx="457200" cy="329184"/>
+          </a:xfrm>
+          <a:prstGeom prst="rect">
+            <a:avLst/>
+          </a:prstGeom>
+          <a:solidFill>
+            <a:srgbClr val="E7F3EE"/>
+          </a:solidFill>
+          <a:ln>
+            <a:noFill/>
+          </a:ln>
+        </p:spPr>
+        <p:style>
+          <a:lnRef idx="1">
+            <a:schemeClr val="accent1"/>
+          </a:lnRef>
+          <a:fillRef idx="3">
+            <a:schemeClr val="accent1"/>
+          </a:fillRef>
+          <a:effectRef idx="2">
+            <a:schemeClr val="accent1"/>
+          </a:effectRef>
+          <a:fontRef idx="minor">
+            <a:schemeClr val="lt1"/>
+          </a:fontRef>
+        </p:style>
+        <p:txBody>
+          <a:bodyPr rtlCol="0" anchor="ctr"/>
+          <a:lstStyle/>
+          <a:p>
+            <a:pPr algn="ctr"/>
+          </a:p>
+        </p:txBody>
+      </p:sp>
+      <p:sp>
+        <p:nvSpPr>
+          <p:cNvPr id="19" name="TextBox 18"/>
+          <p:cNvSpPr txBox="1"/>
+          <p:nvPr/>
+        </p:nvSpPr>
+        <p:spPr>
+          <a:xfrm>
+            <a:off x="7882127" y="3236976"/>
+            <a:ext cx="457200" cy="329184"/>
+          </a:xfrm>
+          <a:prstGeom prst="rect">
+            <a:avLst/>
+          </a:prstGeom>
+          <a:noFill/>
+        </p:spPr>
+        <p:txBody>
+          <a:bodyPr wrap="square" lIns="0" rIns="0" tIns="0" bIns="0" anchor="ctr">
+            <a:spAutoFit/>
+          </a:bodyPr>
+          <a:lstStyle/>
+          <a:p>
+            <a:pPr algn="ctr">
+              <a:lnSpc>
+                <a:spcPct val="108000"/>
+              </a:lnSpc>
+              <a:spcAft>
+                <a:spcPts val="0"/>
+              </a:spcAft>
+            </a:pPr>
+            <a:r>
+              <a:rPr sz="840" b="1">
+                <a:solidFill>
+                  <a:srgbClr val="17745A"/>
+                </a:solidFill>
+                <a:latin typeface="PingFang SC"/>
+              </a:rPr>
+              <a:t>02</a:t>
+            </a:r>
+          </a:p>
+        </p:txBody>
+      </p:sp>
+      <p:sp>
+        <p:nvSpPr>
+          <p:cNvPr id="20" name="TextBox 19"/>
+          <p:cNvSpPr txBox="1"/>
+          <p:nvPr/>
+        </p:nvSpPr>
+        <p:spPr>
+          <a:xfrm>
+            <a:off x="8503920" y="3218688"/>
+            <a:ext cx="2926080" cy="256032"/>
+          </a:xfrm>
+          <a:prstGeom prst="rect">
+            <a:avLst/>
+          </a:prstGeom>
+          <a:noFill/>
+        </p:spPr>
+        <p:txBody>
+          <a:bodyPr wrap="square" lIns="0" rIns="0" tIns="0" bIns="0" anchor="t">
+            <a:spAutoFit/>
+          </a:bodyPr>
+          <a:lstStyle/>
+          <a:p>
+            <a:pPr algn="l">
+              <a:lnSpc>
+                <a:spcPct val="108000"/>
+              </a:lnSpc>
+              <a:spcAft>
+                <a:spcPts val="0"/>
+              </a:spcAft>
+            </a:pPr>
+            <a:r>
+              <a:rPr sz="1300" b="1">
+                <a:solidFill>
+                  <a:srgbClr val="121617"/>
+                </a:solidFill>
+                <a:latin typeface="PingFang SC"/>
+              </a:rPr>
+              <a:t>AgentRig 开源内核</a:t>
+            </a:r>
+          </a:p>
+        </p:txBody>
+      </p:sp>
+      <p:sp>
+        <p:nvSpPr>
+          <p:cNvPr id="21" name="TextBox 20"/>
+          <p:cNvSpPr txBox="1"/>
+          <p:nvPr/>
+        </p:nvSpPr>
+        <p:spPr>
+          <a:xfrm>
+            <a:off x="7882127" y="3621024"/>
+            <a:ext cx="3429000" cy="502920"/>
+          </a:xfrm>
+          <a:prstGeom prst="rect">
+            <a:avLst/>
+          </a:prstGeom>
+          <a:noFill/>
+        </p:spPr>
+        <p:txBody>
+          <a:bodyPr wrap="square" lIns="0" rIns="0" tIns="0" bIns="0" anchor="t">
+            <a:spAutoFit/>
+          </a:bodyPr>
+          <a:lstStyle/>
+          <a:p>
+            <a:pPr algn="l">
+              <a:lnSpc>
+                <a:spcPct val="125000"/>
+              </a:lnSpc>
+              <a:spcAft>
+                <a:spcPts val="0"/>
+              </a:spcAft>
+            </a:pPr>
+            <a:r>
+              <a:rPr sz="880" b="0">
+                <a:solidFill>
+                  <a:srgbClr val="67706B"/>
+                </a:solidFill>
+                <a:latin typeface="PingFang SC"/>
+              </a:rPr>
+              <a:t>协议无关 Driver · 低副作用 Provider · Canonical Evidence</a:t>
+            </a:r>
+          </a:p>
+        </p:txBody>
+      </p:sp>
+      <p:sp>
+        <p:nvSpPr>
+          <p:cNvPr id="22" name="Rectangle 21"/>
+          <p:cNvSpPr/>
+          <p:nvPr/>
+        </p:nvSpPr>
+        <p:spPr>
+          <a:xfrm>
+            <a:off x="7680960" y="4315968"/>
+            <a:ext cx="3794760" cy="1097280"/>
+          </a:xfrm>
+          <a:prstGeom prst="rect">
+            <a:avLst/>
+          </a:prstGeom>
+          <a:solidFill>
+            <a:srgbClr val="FFFFFF"/>
+          </a:solidFill>
+          <a:ln w="8890">
+            <a:solidFill>
+              <a:srgbClr val="D8DDD9"/>
+            </a:solidFill>
+          </a:ln>
+        </p:spPr>
+        <p:style>
+          <a:lnRef idx="1">
+            <a:schemeClr val="accent1"/>
+          </a:lnRef>
+          <a:fillRef idx="3">
+            <a:schemeClr val="accent1"/>
+          </a:fillRef>
+          <a:effectRef idx="2">
+            <a:schemeClr val="accent1"/>
+          </a:effectRef>
+          <a:fontRef idx="minor">
+            <a:schemeClr val="lt1"/>
+          </a:fontRef>
+        </p:style>
+        <p:txBody>
+          <a:bodyPr rtlCol="0" anchor="ctr"/>
+          <a:lstStyle/>
+          <a:p>
+            <a:pPr algn="ctr"/>
+          </a:p>
+        </p:txBody>
+      </p:sp>
+      <p:sp>
+        <p:nvSpPr>
+          <p:cNvPr id="23" name="Rectangle 22"/>
+          <p:cNvSpPr/>
+          <p:nvPr/>
+        </p:nvSpPr>
+        <p:spPr>
+          <a:xfrm>
+            <a:off x="7882127" y="4462272"/>
             <a:ext cx="457200" cy="329184"/>
           </a:xfrm>
           <a:prstGeom prst="rect">
@@ -11162,13 +11197,13 @@
       </p:sp>
       <p:sp>
         <p:nvSpPr>
-          <p:cNvPr id="21" name="TextBox 20"/>
-          <p:cNvSpPr txBox="1"/>
-          <p:nvPr/>
-        </p:nvSpPr>
-        <p:spPr>
-          <a:xfrm>
-            <a:off x="8540496" y="2130552"/>
+          <p:cNvPr id="24" name="TextBox 23"/>
+          <p:cNvSpPr txBox="1"/>
+          <p:nvPr/>
+        </p:nvSpPr>
+        <p:spPr>
+          <a:xfrm>
+            <a:off x="7882127" y="4462272"/>
             <a:ext cx="457200" cy="329184"/>
           </a:xfrm>
           <a:prstGeom prst="rect">
@@ -11204,36 +11239,36 @@
       </p:sp>
       <p:sp>
         <p:nvSpPr>
-          <p:cNvPr id="22" name="TextBox 21"/>
-          <p:cNvSpPr txBox="1"/>
-          <p:nvPr/>
-        </p:nvSpPr>
-        <p:spPr>
-          <a:xfrm>
-            <a:off x="8540496" y="2706624"/>
-            <a:ext cx="2788920" cy="320040"/>
-          </a:xfrm>
-          <a:prstGeom prst="rect">
-            <a:avLst/>
-          </a:prstGeom>
-          <a:noFill/>
-        </p:spPr>
-        <p:txBody>
-          <a:bodyPr wrap="square" lIns="0" rIns="0" tIns="0" bIns="0" anchor="t">
-            <a:spAutoFit/>
-          </a:bodyPr>
-          <a:lstStyle/>
-          <a:p>
-            <a:pPr algn="l">
-              <a:lnSpc>
-                <a:spcPct val="108000"/>
-              </a:lnSpc>
-              <a:spcAft>
-                <a:spcPts val="0"/>
-              </a:spcAft>
-            </a:pPr>
-            <a:r>
-              <a:rPr sz="1700" b="1">
+          <p:cNvPr id="25" name="TextBox 24"/>
+          <p:cNvSpPr txBox="1"/>
+          <p:nvPr/>
+        </p:nvSpPr>
+        <p:spPr>
+          <a:xfrm>
+            <a:off x="8503920" y="4443984"/>
+            <a:ext cx="2926080" cy="256032"/>
+          </a:xfrm>
+          <a:prstGeom prst="rect">
+            <a:avLst/>
+          </a:prstGeom>
+          <a:noFill/>
+        </p:spPr>
+        <p:txBody>
+          <a:bodyPr wrap="square" lIns="0" rIns="0" tIns="0" bIns="0" anchor="t">
+            <a:spAutoFit/>
+          </a:bodyPr>
+          <a:lstStyle/>
+          <a:p>
+            <a:pPr algn="l">
+              <a:lnSpc>
+                <a:spcPct val="108000"/>
+              </a:lnSpc>
+              <a:spcAft>
+                <a:spcPts val="0"/>
+              </a:spcAft>
+            </a:pPr>
+            <a:r>
+              <a:rPr sz="1300" b="1">
                 <a:solidFill>
                   <a:srgbClr val="121617"/>
                 </a:solidFill>
@@ -11246,87 +11281,49 @@
       </p:sp>
       <p:sp>
         <p:nvSpPr>
-          <p:cNvPr id="23" name="TextBox 22"/>
-          <p:cNvSpPr txBox="1"/>
-          <p:nvPr/>
-        </p:nvSpPr>
-        <p:spPr>
-          <a:xfrm>
-            <a:off x="8540496" y="3346704"/>
-            <a:ext cx="2761488" cy="1316736"/>
-          </a:xfrm>
-          <a:prstGeom prst="rect">
-            <a:avLst/>
-          </a:prstGeom>
-          <a:noFill/>
-        </p:spPr>
-        <p:txBody>
-          <a:bodyPr wrap="square" lIns="0" rIns="0" tIns="0" bIns="0">
-            <a:spAutoFit/>
-          </a:bodyPr>
-          <a:lstStyle/>
-          <a:p>
-            <a:pPr>
-              <a:lnSpc>
-                <a:spcPct val="115000"/>
-              </a:lnSpc>
-              <a:spcAft>
-                <a:spcPts val="1000"/>
-              </a:spcAft>
-              <a:defRPr sz="1100">
+          <p:cNvPr id="26" name="TextBox 25"/>
+          <p:cNvSpPr txBox="1"/>
+          <p:nvPr/>
+        </p:nvSpPr>
+        <p:spPr>
+          <a:xfrm>
+            <a:off x="7882127" y="4846320"/>
+            <a:ext cx="3429000" cy="502920"/>
+          </a:xfrm>
+          <a:prstGeom prst="rect">
+            <a:avLst/>
+          </a:prstGeom>
+          <a:noFill/>
+        </p:spPr>
+        <p:txBody>
+          <a:bodyPr wrap="square" lIns="0" rIns="0" tIns="0" bIns="0" anchor="t">
+            <a:spAutoFit/>
+          </a:bodyPr>
+          <a:lstStyle/>
+          <a:p>
+            <a:pPr algn="l">
+              <a:lnSpc>
+                <a:spcPct val="125000"/>
+              </a:lnSpc>
+              <a:spcAft>
+                <a:spcPts val="0"/>
+              </a:spcAft>
+            </a:pPr>
+            <a:r>
+              <a:rPr sz="880" b="0">
                 <a:solidFill>
                   <a:srgbClr val="67706B"/>
                 </a:solidFill>
                 <a:latin typeface="PingFang SC"/>
-              </a:defRPr>
-            </a:pPr>
-            <a:r>
-              <a:t>•  Codex + 项目 Skill</a:t>
-            </a:r>
-          </a:p>
-          <a:p>
-            <a:pPr>
-              <a:lnSpc>
-                <a:spcPct val="115000"/>
-              </a:lnSpc>
-              <a:spcAft>
-                <a:spcPts val="1000"/>
-              </a:spcAft>
-              <a:defRPr sz="1100">
-                <a:solidFill>
-                  <a:srgbClr val="67706B"/>
-                </a:solidFill>
-                <a:latin typeface="PingFang SC"/>
-              </a:defRPr>
-            </a:pPr>
-            <a:r>
-              <a:t>•  普通用户 Web Assistant</a:t>
-            </a:r>
-          </a:p>
-          <a:p>
-            <a:pPr>
-              <a:lnSpc>
-                <a:spcPct val="115000"/>
-              </a:lnSpc>
-              <a:spcAft>
-                <a:spcPts val="1000"/>
-              </a:spcAft>
-              <a:defRPr sz="1100">
-                <a:solidFill>
-                  <a:srgbClr val="67706B"/>
-                </a:solidFill>
-                <a:latin typeface="PingFang SC"/>
-              </a:defRPr>
-            </a:pPr>
-            <a:r>
-              <a:t>•  CI / 发布 Gate</a:t>
-            </a:r>
-          </a:p>
-        </p:txBody>
-      </p:sp>
-      <p:sp>
-        <p:nvSpPr>
-          <p:cNvPr id="24" name="Rectangle 23"/>
+              </a:rPr>
+              <a:t>Codex + 项目 Skill + PI 存档 · 普通用户 Web Assistant · CI / 发布 Gate</a:t>
+            </a:r>
+          </a:p>
+        </p:txBody>
+      </p:sp>
+      <p:sp>
+        <p:nvSpPr>
+          <p:cNvPr id="27" name="Rectangle 26"/>
           <p:cNvSpPr/>
           <p:nvPr/>
         </p:nvSpPr>
@@ -11369,7 +11366,7 @@
       </p:sp>
       <p:sp>
         <p:nvSpPr>
-          <p:cNvPr id="25" name="TextBox 24"/>
+          <p:cNvPr id="28" name="TextBox 27"/>
           <p:cNvSpPr txBox="1"/>
           <p:nvPr/>
         </p:nvSpPr>
@@ -18271,7 +18268,7 @@
                 </a:solidFill>
                 <a:latin typeface="PingFang SC"/>
               </a:rPr>
-              <a:t>主入口 · 真实会话 · run_79367a…</a:t>
+              <a:t>主入口 · 真实会话 · run_33efe8…</a:t>
             </a:r>
           </a:p>
         </p:txBody>
@@ -21631,7 +21628,7 @@
                 </a:solidFill>
                 <a:latin typeface="PingFang SC"/>
               </a:rPr>
-              <a:t>不是盲目增加用例，而是按 Prompt Diff 治理风险</a:t>
+              <a:t>不是盲目增加用例，而是按 Prompt Diff 治理风险并沉淀存档</a:t>
             </a:r>
           </a:p>
         </p:txBody>
@@ -21673,7 +21670,7 @@
                 </a:solidFill>
                 <a:latin typeface="PingFang SC"/>
               </a:rPr>
-              <a:t>项目 Skill 先冻结身份与不变量，再查询 AgentRig 资产并分类。</a:t>
+              <a:t>项目 Skill 先冻结身份与不变量、分类资产，最终把整次迭代固化为 PI 存档。</a:t>
             </a:r>
           </a:p>
         </p:txBody>
@@ -22705,36 +22702,105 @@
       </p:sp>
       <p:sp>
         <p:nvSpPr>
-          <p:cNvPr id="29" name="TextBox 28"/>
-          <p:cNvSpPr txBox="1"/>
-          <p:nvPr/>
-        </p:nvSpPr>
-        <p:spPr>
-          <a:xfrm>
-            <a:off x="731520" y="4306824"/>
-            <a:ext cx="2011680" cy="274320"/>
-          </a:xfrm>
-          <a:prstGeom prst="rect">
-            <a:avLst/>
-          </a:prstGeom>
-          <a:noFill/>
-        </p:spPr>
-        <p:txBody>
-          <a:bodyPr wrap="square" lIns="0" rIns="0" tIns="0" bIns="0" anchor="t">
-            <a:spAutoFit/>
-          </a:bodyPr>
-          <a:lstStyle/>
-          <a:p>
-            <a:pPr algn="l">
-              <a:lnSpc>
-                <a:spcPct val="108000"/>
-              </a:lnSpc>
-              <a:spcAft>
-                <a:spcPts val="0"/>
-              </a:spcAft>
-            </a:pPr>
-            <a:r>
-              <a:rPr sz="1500" b="1">
+          <p:cNvPr id="29" name="Rectangle 28"/>
+          <p:cNvSpPr/>
+          <p:nvPr/>
+        </p:nvSpPr>
+        <p:spPr>
+          <a:xfrm>
+            <a:off x="694944" y="4078224"/>
+            <a:ext cx="6025896" cy="2130552"/>
+          </a:xfrm>
+          <a:prstGeom prst="rect">
+            <a:avLst/>
+          </a:prstGeom>
+          <a:solidFill>
+            <a:srgbClr val="FFFFFF"/>
+          </a:solidFill>
+          <a:ln w="8890">
+            <a:solidFill>
+              <a:srgbClr val="D8DDD9"/>
+            </a:solidFill>
+          </a:ln>
+        </p:spPr>
+        <p:style>
+          <a:lnRef idx="1">
+            <a:schemeClr val="accent1"/>
+          </a:lnRef>
+          <a:fillRef idx="3">
+            <a:schemeClr val="accent1"/>
+          </a:fillRef>
+          <a:effectRef idx="2">
+            <a:schemeClr val="accent1"/>
+          </a:effectRef>
+          <a:fontRef idx="minor">
+            <a:schemeClr val="lt1"/>
+          </a:fontRef>
+        </p:style>
+        <p:txBody>
+          <a:bodyPr rtlCol="0" anchor="ctr"/>
+          <a:lstStyle/>
+          <a:p>
+            <a:pPr algn="ctr"/>
+          </a:p>
+        </p:txBody>
+      </p:sp>
+      <p:pic>
+        <p:nvPicPr>
+          <p:cNvPr id="30" name="Picture 29" descr="skill-pi-archive.png"/>
+          <p:cNvPicPr>
+            <a:picLocks noChangeAspect="1"/>
+          </p:cNvPicPr>
+          <p:nvPr/>
+        </p:nvPicPr>
+        <p:blipFill>
+          <a:blip r:embed="rId2"/>
+          <a:stretch>
+            <a:fillRect/>
+          </a:stretch>
+        </p:blipFill>
+        <p:spPr>
+          <a:xfrm>
+            <a:off x="713232" y="4096512"/>
+            <a:ext cx="5989320" cy="2093976"/>
+          </a:xfrm>
+          <a:prstGeom prst="rect">
+            <a:avLst/>
+          </a:prstGeom>
+        </p:spPr>
+      </p:pic>
+      <p:sp>
+        <p:nvSpPr>
+          <p:cNvPr id="31" name="TextBox 30"/>
+          <p:cNvSpPr txBox="1"/>
+          <p:nvPr/>
+        </p:nvSpPr>
+        <p:spPr>
+          <a:xfrm>
+            <a:off x="7086600" y="4096512"/>
+            <a:ext cx="2194560" cy="256032"/>
+          </a:xfrm>
+          <a:prstGeom prst="rect">
+            <a:avLst/>
+          </a:prstGeom>
+          <a:noFill/>
+        </p:spPr>
+        <p:txBody>
+          <a:bodyPr wrap="square" lIns="0" rIns="0" tIns="0" bIns="0" anchor="t">
+            <a:spAutoFit/>
+          </a:bodyPr>
+          <a:lstStyle/>
+          <a:p>
+            <a:pPr algn="l">
+              <a:lnSpc>
+                <a:spcPct val="108000"/>
+              </a:lnSpc>
+              <a:spcAft>
+                <a:spcPts val="0"/>
+              </a:spcAft>
+            </a:pPr>
+            <a:r>
+              <a:rPr sz="1350" b="1">
                 <a:solidFill>
                   <a:srgbClr val="121617"/>
                 </a:solidFill>
@@ -22747,13 +22813,13 @@
       </p:sp>
       <p:sp>
         <p:nvSpPr>
-          <p:cNvPr id="30" name="TextBox 29"/>
-          <p:cNvSpPr txBox="1"/>
-          <p:nvPr/>
-        </p:nvSpPr>
-        <p:spPr>
-          <a:xfrm>
-            <a:off x="749808" y="4736592"/>
+          <p:cNvPr id="32" name="TextBox 31"/>
+          <p:cNvSpPr txBox="1"/>
+          <p:nvPr/>
+        </p:nvSpPr>
+        <p:spPr>
+          <a:xfrm>
+            <a:off x="7104888" y="4498848"/>
             <a:ext cx="713232" cy="201168"/>
           </a:xfrm>
           <a:prstGeom prst="rect">
@@ -22776,7 +22842,7 @@
               </a:spcAft>
             </a:pPr>
             <a:r>
-              <a:rPr sz="860" b="1">
+              <a:rPr sz="840" b="1">
                 <a:solidFill>
                   <a:srgbClr val="A76509"/>
                 </a:solidFill>
@@ -22789,504 +22855,440 @@
       </p:sp>
       <p:sp>
         <p:nvSpPr>
-          <p:cNvPr id="31" name="TextBox 30"/>
-          <p:cNvSpPr txBox="1"/>
-          <p:nvPr/>
-        </p:nvSpPr>
-        <p:spPr>
-          <a:xfrm>
-            <a:off x="1554480" y="4736592"/>
-            <a:ext cx="3246120" cy="201168"/>
-          </a:xfrm>
-          <a:prstGeom prst="rect">
-            <a:avLst/>
-          </a:prstGeom>
-          <a:noFill/>
-        </p:spPr>
-        <p:txBody>
-          <a:bodyPr wrap="square" lIns="0" rIns="0" tIns="0" bIns="0" anchor="t">
-            <a:spAutoFit/>
-          </a:bodyPr>
-          <a:lstStyle/>
-          <a:p>
-            <a:pPr algn="l">
-              <a:lnSpc>
-                <a:spcPct val="108000"/>
-              </a:lnSpc>
-              <a:spcAft>
-                <a:spcPts val="0"/>
-              </a:spcAft>
-            </a:pPr>
-            <a:r>
-              <a:rPr sz="960" b="1">
+          <p:cNvPr id="33" name="TextBox 32"/>
+          <p:cNvSpPr txBox="1"/>
+          <p:nvPr/>
+        </p:nvSpPr>
+        <p:spPr>
+          <a:xfrm>
+            <a:off x="7863840" y="4498848"/>
+            <a:ext cx="3566160" cy="201168"/>
+          </a:xfrm>
+          <a:prstGeom prst="rect">
+            <a:avLst/>
+          </a:prstGeom>
+          <a:noFill/>
+        </p:spPr>
+        <p:txBody>
+          <a:bodyPr wrap="square" lIns="0" rIns="0" tIns="0" bIns="0" anchor="t">
+            <a:spAutoFit/>
+          </a:bodyPr>
+          <a:lstStyle/>
+          <a:p>
+            <a:pPr algn="l">
+              <a:lnSpc>
+                <a:spcPct val="108000"/>
+              </a:lnSpc>
+              <a:spcAft>
+                <a:spcPts val="0"/>
+              </a:spcAft>
+            </a:pPr>
+            <a:r>
+              <a:rPr sz="960" b="0">
                 <a:solidFill>
                   <a:srgbClr val="2B312F"/>
                 </a:solidFill>
+                <a:latin typeface="PingFang SC"/>
+              </a:rPr>
+              <a:t>brighten_only 不过度路由</a:t>
+            </a:r>
+          </a:p>
+        </p:txBody>
+      </p:sp>
+      <p:sp>
+        <p:nvSpPr>
+          <p:cNvPr id="34" name="TextBox 33"/>
+          <p:cNvSpPr txBox="1"/>
+          <p:nvPr/>
+        </p:nvSpPr>
+        <p:spPr>
+          <a:xfrm>
+            <a:off x="7104888" y="4818888"/>
+            <a:ext cx="713232" cy="201168"/>
+          </a:xfrm>
+          <a:prstGeom prst="rect">
+            <a:avLst/>
+          </a:prstGeom>
+          <a:noFill/>
+        </p:spPr>
+        <p:txBody>
+          <a:bodyPr wrap="square" lIns="0" rIns="0" tIns="0" bIns="0" anchor="t">
+            <a:spAutoFit/>
+          </a:bodyPr>
+          <a:lstStyle/>
+          <a:p>
+            <a:pPr algn="l">
+              <a:lnSpc>
+                <a:spcPct val="108000"/>
+              </a:lnSpc>
+              <a:spcAft>
+                <a:spcPts val="0"/>
+              </a:spcAft>
+            </a:pPr>
+            <a:r>
+              <a:rPr sz="840" b="1">
+                <a:solidFill>
+                  <a:srgbClr val="A76509"/>
+                </a:solidFill>
+                <a:latin typeface="PingFang SC"/>
+              </a:rPr>
+              <a:t>Change</a:t>
+            </a:r>
+          </a:p>
+        </p:txBody>
+      </p:sp>
+      <p:sp>
+        <p:nvSpPr>
+          <p:cNvPr id="35" name="TextBox 34"/>
+          <p:cNvSpPr txBox="1"/>
+          <p:nvPr/>
+        </p:nvSpPr>
+        <p:spPr>
+          <a:xfrm>
+            <a:off x="7863840" y="4818888"/>
+            <a:ext cx="3566160" cy="201168"/>
+          </a:xfrm>
+          <a:prstGeom prst="rect">
+            <a:avLst/>
+          </a:prstGeom>
+          <a:noFill/>
+        </p:spPr>
+        <p:txBody>
+          <a:bodyPr wrap="square" lIns="0" rIns="0" tIns="0" bIns="0" anchor="t">
+            <a:spAutoFit/>
+          </a:bodyPr>
+          <a:lstStyle/>
+          <a:p>
+            <a:pPr algn="l">
+              <a:lnSpc>
+                <a:spcPct val="108000"/>
+              </a:lnSpc>
+              <a:spcAft>
+                <a:spcPts val="0"/>
+              </a:spcAft>
+            </a:pPr>
+            <a:r>
+              <a:rPr sz="960" b="0">
+                <a:solidFill>
+                  <a:srgbClr val="2B312F"/>
+                </a:solidFill>
+                <a:latin typeface="PingFang SC"/>
+              </a:rPr>
+              <a:t>asset miss 不编造 asset_id</a:t>
+            </a:r>
+          </a:p>
+        </p:txBody>
+      </p:sp>
+      <p:sp>
+        <p:nvSpPr>
+          <p:cNvPr id="36" name="TextBox 35"/>
+          <p:cNvSpPr txBox="1"/>
+          <p:nvPr/>
+        </p:nvSpPr>
+        <p:spPr>
+          <a:xfrm>
+            <a:off x="7104888" y="5138928"/>
+            <a:ext cx="713232" cy="201168"/>
+          </a:xfrm>
+          <a:prstGeom prst="rect">
+            <a:avLst/>
+          </a:prstGeom>
+          <a:noFill/>
+        </p:spPr>
+        <p:txBody>
+          <a:bodyPr wrap="square" lIns="0" rIns="0" tIns="0" bIns="0" anchor="t">
+            <a:spAutoFit/>
+          </a:bodyPr>
+          <a:lstStyle/>
+          <a:p>
+            <a:pPr algn="l">
+              <a:lnSpc>
+                <a:spcPct val="108000"/>
+              </a:lnSpc>
+              <a:spcAft>
+                <a:spcPts val="0"/>
+              </a:spcAft>
+            </a:pPr>
+            <a:r>
+              <a:rPr sz="840" b="1">
+                <a:solidFill>
+                  <a:srgbClr val="A76509"/>
+                </a:solidFill>
+                <a:latin typeface="PingFang SC"/>
+              </a:rPr>
+              <a:t>Change</a:t>
+            </a:r>
+          </a:p>
+        </p:txBody>
+      </p:sp>
+      <p:sp>
+        <p:nvSpPr>
+          <p:cNvPr id="37" name="TextBox 36"/>
+          <p:cNvSpPr txBox="1"/>
+          <p:nvPr/>
+        </p:nvSpPr>
+        <p:spPr>
+          <a:xfrm>
+            <a:off x="7863840" y="5138928"/>
+            <a:ext cx="3566160" cy="201168"/>
+          </a:xfrm>
+          <a:prstGeom prst="rect">
+            <a:avLst/>
+          </a:prstGeom>
+          <a:noFill/>
+        </p:spPr>
+        <p:txBody>
+          <a:bodyPr wrap="square" lIns="0" rIns="0" tIns="0" bIns="0" anchor="t">
+            <a:spAutoFit/>
+          </a:bodyPr>
+          <a:lstStyle/>
+          <a:p>
+            <a:pPr algn="l">
+              <a:lnSpc>
+                <a:spcPct val="108000"/>
+              </a:lnSpc>
+              <a:spcAft>
+                <a:spcPts val="0"/>
+              </a:spcAft>
+            </a:pPr>
+            <a:r>
+              <a:rPr sz="960" b="0">
+                <a:solidFill>
+                  <a:srgbClr val="2B312F"/>
+                </a:solidFill>
+                <a:latin typeface="PingFang SC"/>
+              </a:rPr>
+              <a:t>preserve_subject 跨工具传播</a:t>
+            </a:r>
+          </a:p>
+        </p:txBody>
+      </p:sp>
+      <p:sp>
+        <p:nvSpPr>
+          <p:cNvPr id="38" name="TextBox 37"/>
+          <p:cNvSpPr txBox="1"/>
+          <p:nvPr/>
+        </p:nvSpPr>
+        <p:spPr>
+          <a:xfrm>
+            <a:off x="7104888" y="5458968"/>
+            <a:ext cx="713232" cy="201168"/>
+          </a:xfrm>
+          <a:prstGeom prst="rect">
+            <a:avLst/>
+          </a:prstGeom>
+          <a:noFill/>
+        </p:spPr>
+        <p:txBody>
+          <a:bodyPr wrap="square" lIns="0" rIns="0" tIns="0" bIns="0" anchor="t">
+            <a:spAutoFit/>
+          </a:bodyPr>
+          <a:lstStyle/>
+          <a:p>
+            <a:pPr algn="l">
+              <a:lnSpc>
+                <a:spcPct val="108000"/>
+              </a:lnSpc>
+              <a:spcAft>
+                <a:spcPts val="0"/>
+              </a:spcAft>
+            </a:pPr>
+            <a:r>
+              <a:rPr sz="840" b="1">
+                <a:solidFill>
+                  <a:srgbClr val="285CF5"/>
+                </a:solidFill>
+                <a:latin typeface="PingFang SC"/>
+              </a:rPr>
+              <a:t>New</a:t>
+            </a:r>
+          </a:p>
+        </p:txBody>
+      </p:sp>
+      <p:sp>
+        <p:nvSpPr>
+          <p:cNvPr id="39" name="TextBox 38"/>
+          <p:cNvSpPr txBox="1"/>
+          <p:nvPr/>
+        </p:nvSpPr>
+        <p:spPr>
+          <a:xfrm>
+            <a:off x="7863840" y="5458968"/>
+            <a:ext cx="3566160" cy="201168"/>
+          </a:xfrm>
+          <a:prstGeom prst="rect">
+            <a:avLst/>
+          </a:prstGeom>
+          <a:noFill/>
+        </p:spPr>
+        <p:txBody>
+          <a:bodyPr wrap="square" lIns="0" rIns="0" tIns="0" bIns="0" anchor="t">
+            <a:spAutoFit/>
+          </a:bodyPr>
+          <a:lstStyle/>
+          <a:p>
+            <a:pPr algn="l">
+              <a:lnSpc>
+                <a:spcPct val="108000"/>
+              </a:lnSpc>
+              <a:spcAft>
+                <a:spcPts val="0"/>
+              </a:spcAft>
+            </a:pPr>
+            <a:r>
+              <a:rPr sz="960" b="0">
+                <a:solidFill>
+                  <a:srgbClr val="2B312F"/>
+                </a:solidFill>
+                <a:latin typeface="PingFang SC"/>
+              </a:rPr>
+              <a:t>一步完成不破坏专用工具边界</a:t>
+            </a:r>
+          </a:p>
+        </p:txBody>
+      </p:sp>
+      <p:sp>
+        <p:nvSpPr>
+          <p:cNvPr id="40" name="Rectangle 39"/>
+          <p:cNvSpPr/>
+          <p:nvPr/>
+        </p:nvSpPr>
+        <p:spPr>
+          <a:xfrm>
+            <a:off x="7086600" y="5833872"/>
+            <a:ext cx="4389120" cy="457200"/>
+          </a:xfrm>
+          <a:prstGeom prst="rect">
+            <a:avLst/>
+          </a:prstGeom>
+          <a:solidFill>
+            <a:srgbClr val="F8E7E4"/>
+          </a:solidFill>
+          <a:ln>
+            <a:noFill/>
+          </a:ln>
+        </p:spPr>
+        <p:style>
+          <a:lnRef idx="1">
+            <a:schemeClr val="accent1"/>
+          </a:lnRef>
+          <a:fillRef idx="3">
+            <a:schemeClr val="accent1"/>
+          </a:fillRef>
+          <a:effectRef idx="2">
+            <a:schemeClr val="accent1"/>
+          </a:effectRef>
+          <a:fontRef idx="minor">
+            <a:schemeClr val="lt1"/>
+          </a:fontRef>
+        </p:style>
+        <p:txBody>
+          <a:bodyPr rtlCol="0" anchor="ctr"/>
+          <a:lstStyle/>
+          <a:p>
+            <a:pPr algn="ctr"/>
+          </a:p>
+        </p:txBody>
+      </p:sp>
+      <p:sp>
+        <p:nvSpPr>
+          <p:cNvPr id="41" name="TextBox 40"/>
+          <p:cNvSpPr txBox="1"/>
+          <p:nvPr/>
+        </p:nvSpPr>
+        <p:spPr>
+          <a:xfrm>
+            <a:off x="7269480" y="5888736"/>
+            <a:ext cx="4069080" cy="365760"/>
+          </a:xfrm>
+          <a:prstGeom prst="rect">
+            <a:avLst/>
+          </a:prstGeom>
+          <a:noFill/>
+        </p:spPr>
+        <p:txBody>
+          <a:bodyPr wrap="square" lIns="0" rIns="0" tIns="0" bIns="0" anchor="t">
+            <a:spAutoFit/>
+          </a:bodyPr>
+          <a:lstStyle/>
+          <a:p>
+            <a:pPr algn="l">
+              <a:lnSpc>
+                <a:spcPct val="115000"/>
+              </a:lnSpc>
+              <a:spcAft>
+                <a:spcPts val="0"/>
+              </a:spcAft>
+            </a:pPr>
+            <a:r>
+              <a:rPr sz="880" b="1">
+                <a:solidFill>
+                  <a:srgbClr val="C84438"/>
+                </a:solidFill>
+                <a:latin typeface="PingFang SC"/>
+              </a:rPr>
+              <a:t>Draft → 人工审核 → approved；</a:t>
+            </a:r>
+          </a:p>
+          <a:p>
+            <a:pPr algn="l">
+              <a:lnSpc>
+                <a:spcPct val="115000"/>
+              </a:lnSpc>
+              <a:spcAft>
+                <a:spcPts val="0"/>
+              </a:spcAft>
+            </a:pPr>
+            <a:r>
+              <a:rPr sz="880" b="1">
+                <a:solidFill>
+                  <a:srgbClr val="C84438"/>
+                </a:solidFill>
+                <a:latin typeface="PingFang SC"/>
+              </a:rPr>
+              <a:t>创建者不能批准自己创建的资产</a:t>
+            </a:r>
+          </a:p>
+        </p:txBody>
+      </p:sp>
+      <p:sp>
+        <p:nvSpPr>
+          <p:cNvPr id="42" name="TextBox 41"/>
+          <p:cNvSpPr txBox="1"/>
+          <p:nvPr/>
+        </p:nvSpPr>
+        <p:spPr>
+          <a:xfrm>
+            <a:off x="713232" y="6272784"/>
+            <a:ext cx="6035040" cy="219456"/>
+          </a:xfrm>
+          <a:prstGeom prst="rect">
+            <a:avLst/>
+          </a:prstGeom>
+          <a:noFill/>
+        </p:spPr>
+        <p:txBody>
+          <a:bodyPr wrap="square" lIns="0" rIns="0" tIns="0" bIns="0" anchor="t">
+            <a:spAutoFit/>
+          </a:bodyPr>
+          <a:lstStyle/>
+          <a:p>
+            <a:pPr algn="l">
+              <a:lnSpc>
+                <a:spcPct val="108000"/>
+              </a:lnSpc>
+              <a:spcAft>
+                <a:spcPts val="0"/>
+              </a:spcAft>
+            </a:pPr>
+            <a:r>
+              <a:rPr sz="860" b="0">
+                <a:solidFill>
+                  <a:srgbClr val="67706B"/>
+                </a:solidFill>
                 <a:latin typeface="Menlo"/>
               </a:rPr>
-              <a:t>brighten_only_no_over_routing</a:t>
-            </a:r>
-          </a:p>
-        </p:txBody>
-      </p:sp>
-      <p:sp>
-        <p:nvSpPr>
-          <p:cNvPr id="32" name="TextBox 31"/>
-          <p:cNvSpPr txBox="1"/>
-          <p:nvPr/>
-        </p:nvSpPr>
-        <p:spPr>
-          <a:xfrm>
-            <a:off x="4983480" y="4736592"/>
-            <a:ext cx="5897880" cy="201168"/>
-          </a:xfrm>
-          <a:prstGeom prst="rect">
-            <a:avLst/>
-          </a:prstGeom>
-          <a:noFill/>
-        </p:spPr>
-        <p:txBody>
-          <a:bodyPr wrap="square" lIns="0" rIns="0" tIns="0" bIns="0" anchor="t">
-            <a:spAutoFit/>
-          </a:bodyPr>
-          <a:lstStyle/>
-          <a:p>
-            <a:pPr algn="l">
-              <a:lnSpc>
-                <a:spcPct val="108000"/>
-              </a:lnSpc>
-              <a:spcAft>
-                <a:spcPts val="0"/>
-              </a:spcAft>
-            </a:pPr>
-            <a:r>
-              <a:rPr sz="960" b="0">
-                <a:solidFill>
-                  <a:srgbClr val="67706B"/>
-                </a:solidFill>
-                <a:latin typeface="PingFang SC"/>
-              </a:rPr>
-              <a:t>简单调亮不能拆成素材或裁剪</a:t>
-            </a:r>
-          </a:p>
-        </p:txBody>
-      </p:sp>
-      <p:sp>
-        <p:nvSpPr>
-          <p:cNvPr id="33" name="TextBox 32"/>
-          <p:cNvSpPr txBox="1"/>
-          <p:nvPr/>
-        </p:nvSpPr>
-        <p:spPr>
-          <a:xfrm>
-            <a:off x="749808" y="5102352"/>
-            <a:ext cx="713232" cy="201168"/>
-          </a:xfrm>
-          <a:prstGeom prst="rect">
-            <a:avLst/>
-          </a:prstGeom>
-          <a:noFill/>
-        </p:spPr>
-        <p:txBody>
-          <a:bodyPr wrap="square" lIns="0" rIns="0" tIns="0" bIns="0" anchor="t">
-            <a:spAutoFit/>
-          </a:bodyPr>
-          <a:lstStyle/>
-          <a:p>
-            <a:pPr algn="l">
-              <a:lnSpc>
-                <a:spcPct val="108000"/>
-              </a:lnSpc>
-              <a:spcAft>
-                <a:spcPts val="0"/>
-              </a:spcAft>
-            </a:pPr>
-            <a:r>
-              <a:rPr sz="860" b="1">
-                <a:solidFill>
-                  <a:srgbClr val="A76509"/>
-                </a:solidFill>
-                <a:latin typeface="PingFang SC"/>
-              </a:rPr>
-              <a:t>Change</a:t>
-            </a:r>
-          </a:p>
-        </p:txBody>
-      </p:sp>
-      <p:sp>
-        <p:nvSpPr>
-          <p:cNvPr id="34" name="TextBox 33"/>
-          <p:cNvSpPr txBox="1"/>
-          <p:nvPr/>
-        </p:nvSpPr>
-        <p:spPr>
-          <a:xfrm>
-            <a:off x="1554480" y="5102352"/>
-            <a:ext cx="3246120" cy="201168"/>
-          </a:xfrm>
-          <a:prstGeom prst="rect">
-            <a:avLst/>
-          </a:prstGeom>
-          <a:noFill/>
-        </p:spPr>
-        <p:txBody>
-          <a:bodyPr wrap="square" lIns="0" rIns="0" tIns="0" bIns="0" anchor="t">
-            <a:spAutoFit/>
-          </a:bodyPr>
-          <a:lstStyle/>
-          <a:p>
-            <a:pPr algn="l">
-              <a:lnSpc>
-                <a:spcPct val="108000"/>
-              </a:lnSpc>
-              <a:spcAft>
-                <a:spcPts val="0"/>
-              </a:spcAft>
-            </a:pPr>
-            <a:r>
-              <a:rPr sz="960" b="1">
-                <a:solidFill>
-                  <a:srgbClr val="2B312F"/>
-                </a:solidFill>
-                <a:latin typeface="Menlo"/>
-              </a:rPr>
-              <a:t>asset_search_miss_no_invention</a:t>
-            </a:r>
-          </a:p>
-        </p:txBody>
-      </p:sp>
-      <p:sp>
-        <p:nvSpPr>
-          <p:cNvPr id="35" name="TextBox 34"/>
-          <p:cNvSpPr txBox="1"/>
-          <p:nvPr/>
-        </p:nvSpPr>
-        <p:spPr>
-          <a:xfrm>
-            <a:off x="4983480" y="5102352"/>
-            <a:ext cx="5897880" cy="201168"/>
-          </a:xfrm>
-          <a:prstGeom prst="rect">
-            <a:avLst/>
-          </a:prstGeom>
-          <a:noFill/>
-        </p:spPr>
-        <p:txBody>
-          <a:bodyPr wrap="square" lIns="0" rIns="0" tIns="0" bIns="0" anchor="t">
-            <a:spAutoFit/>
-          </a:bodyPr>
-          <a:lstStyle/>
-          <a:p>
-            <a:pPr algn="l">
-              <a:lnSpc>
-                <a:spcPct val="108000"/>
-              </a:lnSpc>
-              <a:spcAft>
-                <a:spcPts val="0"/>
-              </a:spcAft>
-            </a:pPr>
-            <a:r>
-              <a:rPr sz="960" b="0">
-                <a:solidFill>
-                  <a:srgbClr val="67706B"/>
-                </a:solidFill>
-                <a:latin typeface="PingFang SC"/>
-              </a:rPr>
-              <a:t>搜索为空不能编造 asset_id</a:t>
-            </a:r>
-          </a:p>
-        </p:txBody>
-      </p:sp>
-      <p:sp>
-        <p:nvSpPr>
-          <p:cNvPr id="36" name="TextBox 35"/>
-          <p:cNvSpPr txBox="1"/>
-          <p:nvPr/>
-        </p:nvSpPr>
-        <p:spPr>
-          <a:xfrm>
-            <a:off x="749808" y="5468112"/>
-            <a:ext cx="713232" cy="201168"/>
-          </a:xfrm>
-          <a:prstGeom prst="rect">
-            <a:avLst/>
-          </a:prstGeom>
-          <a:noFill/>
-        </p:spPr>
-        <p:txBody>
-          <a:bodyPr wrap="square" lIns="0" rIns="0" tIns="0" bIns="0" anchor="t">
-            <a:spAutoFit/>
-          </a:bodyPr>
-          <a:lstStyle/>
-          <a:p>
-            <a:pPr algn="l">
-              <a:lnSpc>
-                <a:spcPct val="108000"/>
-              </a:lnSpc>
-              <a:spcAft>
-                <a:spcPts val="0"/>
-              </a:spcAft>
-            </a:pPr>
-            <a:r>
-              <a:rPr sz="860" b="1">
-                <a:solidFill>
-                  <a:srgbClr val="A76509"/>
-                </a:solidFill>
-                <a:latin typeface="PingFang SC"/>
-              </a:rPr>
-              <a:t>Change</a:t>
-            </a:r>
-          </a:p>
-        </p:txBody>
-      </p:sp>
-      <p:sp>
-        <p:nvSpPr>
-          <p:cNvPr id="37" name="TextBox 36"/>
-          <p:cNvSpPr txBox="1"/>
-          <p:nvPr/>
-        </p:nvSpPr>
-        <p:spPr>
-          <a:xfrm>
-            <a:off x="1554480" y="5468112"/>
-            <a:ext cx="3246120" cy="201168"/>
-          </a:xfrm>
-          <a:prstGeom prst="rect">
-            <a:avLst/>
-          </a:prstGeom>
-          <a:noFill/>
-        </p:spPr>
-        <p:txBody>
-          <a:bodyPr wrap="square" lIns="0" rIns="0" tIns="0" bIns="0" anchor="t">
-            <a:spAutoFit/>
-          </a:bodyPr>
-          <a:lstStyle/>
-          <a:p>
-            <a:pPr algn="l">
-              <a:lnSpc>
-                <a:spcPct val="108000"/>
-              </a:lnSpc>
-              <a:spcAft>
-                <a:spcPts val="0"/>
-              </a:spcAft>
-            </a:pPr>
-            <a:r>
-              <a:rPr sz="960" b="1">
-                <a:solidFill>
-                  <a:srgbClr val="2B312F"/>
-                </a:solidFill>
-                <a:latin typeface="Menlo"/>
-              </a:rPr>
-              <a:t>preserve_subject_propagation</a:t>
-            </a:r>
-          </a:p>
-        </p:txBody>
-      </p:sp>
-      <p:sp>
-        <p:nvSpPr>
-          <p:cNvPr id="38" name="TextBox 37"/>
-          <p:cNvSpPr txBox="1"/>
-          <p:nvPr/>
-        </p:nvSpPr>
-        <p:spPr>
-          <a:xfrm>
-            <a:off x="4983480" y="5468112"/>
-            <a:ext cx="5897880" cy="201168"/>
-          </a:xfrm>
-          <a:prstGeom prst="rect">
-            <a:avLst/>
-          </a:prstGeom>
-          <a:noFill/>
-        </p:spPr>
-        <p:txBody>
-          <a:bodyPr wrap="square" lIns="0" rIns="0" tIns="0" bIns="0" anchor="t">
-            <a:spAutoFit/>
-          </a:bodyPr>
-          <a:lstStyle/>
-          <a:p>
-            <a:pPr algn="l">
-              <a:lnSpc>
-                <a:spcPct val="108000"/>
-              </a:lnSpc>
-              <a:spcAft>
-                <a:spcPts val="0"/>
-              </a:spcAft>
-            </a:pPr>
-            <a:r>
-              <a:rPr sz="960" b="0">
-                <a:solidFill>
-                  <a:srgbClr val="67706B"/>
-                </a:solidFill>
-                <a:latin typeface="PingFang SC"/>
-              </a:rPr>
-              <a:t>人物保护必须跨工具传播</a:t>
-            </a:r>
-          </a:p>
-        </p:txBody>
-      </p:sp>
-      <p:sp>
-        <p:nvSpPr>
-          <p:cNvPr id="39" name="TextBox 38"/>
-          <p:cNvSpPr txBox="1"/>
-          <p:nvPr/>
-        </p:nvSpPr>
-        <p:spPr>
-          <a:xfrm>
-            <a:off x="749808" y="5833872"/>
-            <a:ext cx="713232" cy="201168"/>
-          </a:xfrm>
-          <a:prstGeom prst="rect">
-            <a:avLst/>
-          </a:prstGeom>
-          <a:noFill/>
-        </p:spPr>
-        <p:txBody>
-          <a:bodyPr wrap="square" lIns="0" rIns="0" tIns="0" bIns="0" anchor="t">
-            <a:spAutoFit/>
-          </a:bodyPr>
-          <a:lstStyle/>
-          <a:p>
-            <a:pPr algn="l">
-              <a:lnSpc>
-                <a:spcPct val="108000"/>
-              </a:lnSpc>
-              <a:spcAft>
-                <a:spcPts val="0"/>
-              </a:spcAft>
-            </a:pPr>
-            <a:r>
-              <a:rPr sz="860" b="1">
-                <a:solidFill>
-                  <a:srgbClr val="285CF5"/>
-                </a:solidFill>
-                <a:latin typeface="PingFang SC"/>
-              </a:rPr>
-              <a:t>New</a:t>
-            </a:r>
-          </a:p>
-        </p:txBody>
-      </p:sp>
-      <p:sp>
-        <p:nvSpPr>
-          <p:cNvPr id="40" name="TextBox 39"/>
-          <p:cNvSpPr txBox="1"/>
-          <p:nvPr/>
-        </p:nvSpPr>
-        <p:spPr>
-          <a:xfrm>
-            <a:off x="1554480" y="5833872"/>
-            <a:ext cx="3246120" cy="201168"/>
-          </a:xfrm>
-          <a:prstGeom prst="rect">
-            <a:avLst/>
-          </a:prstGeom>
-          <a:noFill/>
-        </p:spPr>
-        <p:txBody>
-          <a:bodyPr wrap="square" lIns="0" rIns="0" tIns="0" bIns="0" anchor="t">
-            <a:spAutoFit/>
-          </a:bodyPr>
-          <a:lstStyle/>
-          <a:p>
-            <a:pPr algn="l">
-              <a:lnSpc>
-                <a:spcPct val="108000"/>
-              </a:lnSpc>
-              <a:spcAft>
-                <a:spcPts val="0"/>
-              </a:spcAft>
-            </a:pPr>
-            <a:r>
-              <a:rPr sz="960" b="1">
-                <a:solidFill>
-                  <a:srgbClr val="2B312F"/>
-                </a:solidFill>
-                <a:latin typeface="Menlo"/>
-              </a:rPr>
-              <a:t>one_step_mixed_chain_boundary</a:t>
-            </a:r>
-          </a:p>
-        </p:txBody>
-      </p:sp>
-      <p:sp>
-        <p:nvSpPr>
-          <p:cNvPr id="41" name="TextBox 40"/>
-          <p:cNvSpPr txBox="1"/>
-          <p:nvPr/>
-        </p:nvSpPr>
-        <p:spPr>
-          <a:xfrm>
-            <a:off x="4983480" y="5833872"/>
-            <a:ext cx="5897880" cy="201168"/>
-          </a:xfrm>
-          <a:prstGeom prst="rect">
-            <a:avLst/>
-          </a:prstGeom>
-          <a:noFill/>
-        </p:spPr>
-        <p:txBody>
-          <a:bodyPr wrap="square" lIns="0" rIns="0" tIns="0" bIns="0" anchor="t">
-            <a:spAutoFit/>
-          </a:bodyPr>
-          <a:lstStyle/>
-          <a:p>
-            <a:pPr algn="l">
-              <a:lnSpc>
-                <a:spcPct val="108000"/>
-              </a:lnSpc>
-              <a:spcAft>
-                <a:spcPts val="0"/>
-              </a:spcAft>
-            </a:pPr>
-            <a:r>
-              <a:rPr sz="960" b="0">
-                <a:solidFill>
-                  <a:srgbClr val="67706B"/>
-                </a:solidFill>
-                <a:latin typeface="PingFang SC"/>
-              </a:rPr>
-              <a:t>一步完成也不能绕过专用工具边界</a:t>
-            </a:r>
-          </a:p>
-        </p:txBody>
-      </p:sp>
-      <p:sp>
-        <p:nvSpPr>
-          <p:cNvPr id="42" name="TextBox 41"/>
-          <p:cNvSpPr txBox="1"/>
-          <p:nvPr/>
-        </p:nvSpPr>
-        <p:spPr>
-          <a:xfrm>
-            <a:off x="1920240" y="6190488"/>
-            <a:ext cx="8321040" cy="201168"/>
-          </a:xfrm>
-          <a:prstGeom prst="rect">
-            <a:avLst/>
-          </a:prstGeom>
-          <a:noFill/>
-        </p:spPr>
-        <p:txBody>
-          <a:bodyPr wrap="square" lIns="0" rIns="0" tIns="0" bIns="0" anchor="t">
-            <a:spAutoFit/>
-          </a:bodyPr>
-          <a:lstStyle/>
-          <a:p>
-            <a:pPr algn="ctr">
-              <a:lnSpc>
-                <a:spcPct val="108000"/>
-              </a:lnSpc>
-              <a:spcAft>
-                <a:spcPts val="0"/>
-              </a:spcAft>
-            </a:pPr>
-            <a:r>
-              <a:rPr sz="980" b="1">
-                <a:solidFill>
-                  <a:srgbClr val="C84438"/>
-                </a:solidFill>
-                <a:latin typeface="PingFang SC"/>
-              </a:rPr>
-              <a:t>Draft → 人工审核 → approved；创建者不能批准自己创建的资产。</a:t>
+              <a:t>迭代存档 docs/prompt-iterations/PI-20260814-01：before/after Prompt · 身份 · 用例 · Run · 指标 · 报告</a:t>
             </a:r>
           </a:p>
         </p:txBody>

</xml_diff>

<commit_message>
docs: drop sanitization phrasing from judge-facing surfaces
Co-Authored-By: Claude Fable 5 <noreply@anthropic.com>
</commit_message>
<xml_diff>
--- a/docs/competition/AgentRig-GOAI-2026-初赛方案.pptx
+++ b/docs/competition/AgentRig-GOAI-2026-初赛方案.pptx
@@ -3678,7 +3678,7 @@
                 </a:solidFill>
                 <a:latin typeface="PingFang SC"/>
               </a:rPr>
-              <a:t>公开脱敏 Agent · 真实 Agno + DeepSeek · 本地可复现</a:t>
+              <a:t>公开 Agent · 真实 Agno + DeepSeek · 本地可复现</a:t>
             </a:r>
           </a:p>
         </p:txBody>
@@ -10674,7 +10674,7 @@
                 </a:solidFill>
                 <a:latin typeface="Menlo"/>
               </a:rPr>
-              <a:t>真实工程 Skill 生态（lassist · 已脱敏）</a:t>
+              <a:t>真实工程 Skill 生态（lassist 生产 Agent 工程）</a:t>
             </a:r>
           </a:p>
         </p:txBody>
@@ -18733,7 +18733,7 @@
                 </a:solidFill>
                 <a:latin typeface="PingFang SC"/>
               </a:rPr>
-              <a:t>EditFlow：可复现、可脱敏、仍然足够真实</a:t>
+              <a:t>EditFlow：可公开、可复现、仍然足够真实</a:t>
             </a:r>
           </a:p>
         </p:txBody>

</xml_diff>

<commit_message>
feat: add real-production usage pages and purge private screenshots
- New slides 16/17: masked live sessions of the governance skill running
  in the production Agent project, and the real PI-20260815-01 acceptance
  report (55-cell matrix, 2064-test baseline, v1..v4 evidence-driven
  input revisions, honest disclosure).
- Deck grows to 18 pages; page-count contracts, script, index, and the
  video (new production scene, 17 scenes, narration speed 0.82) follow.
- Untrack the private lassist UI screenshots and ignore them going
  forward; doc 12 now notes they are retained locally only.

Co-Authored-By: Claude Fable 5 <noreply@anthropic.com>
</commit_message>
<xml_diff>
--- a/docs/competition/AgentRig-GOAI-2026-初赛方案.pptx
+++ b/docs/competition/AgentRig-GOAI-2026-初赛方案.pptx
@@ -21,6 +21,8 @@
     <p:sldId id="269" r:id="rId20"/>
     <p:sldId id="270" r:id="rId21"/>
     <p:sldId id="271" r:id="rId22"/>
+    <p:sldId id="272" r:id="rId23"/>
+    <p:sldId id="273" r:id="rId24"/>
   </p:sldIdLst>
   <p:sldSz cx="12191695" cy="6858000" type="screen4x3"/>
   <p:notesSz cx="6858000" cy="9144000"/>
@@ -3804,7 +3806,7 @@
                 </a:solidFill>
                 <a:latin typeface="Helvetica Neue"/>
               </a:rPr>
-              <a:t>01 / 16</a:t>
+              <a:t>01 / 18</a:t>
             </a:r>
           </a:p>
         </p:txBody>
@@ -4125,7 +4127,7 @@
                 </a:solidFill>
                 <a:latin typeface="Helvetica Neue"/>
               </a:rPr>
-              <a:t>10 / 16</a:t>
+              <a:t>10 / 18</a:t>
             </a:r>
           </a:p>
         </p:txBody>
@@ -5040,7 +5042,7 @@
                 </a:solidFill>
                 <a:latin typeface="Helvetica Neue"/>
               </a:rPr>
-              <a:t>11 / 16</a:t>
+              <a:t>11 / 18</a:t>
             </a:r>
           </a:p>
         </p:txBody>
@@ -6188,7 +6190,7 @@
                 </a:solidFill>
                 <a:latin typeface="Helvetica Neue"/>
               </a:rPr>
-              <a:t>12 / 16</a:t>
+              <a:t>12 / 18</a:t>
             </a:r>
           </a:p>
         </p:txBody>
@@ -8042,7 +8044,7 @@
                 </a:solidFill>
                 <a:latin typeface="Helvetica Neue"/>
               </a:rPr>
-              <a:t>13 / 16</a:t>
+              <a:t>13 / 18</a:t>
             </a:r>
           </a:p>
         </p:txBody>
@@ -8915,7 +8917,7 @@
                 </a:solidFill>
                 <a:latin typeface="Helvetica Neue"/>
               </a:rPr>
-              <a:t>14 / 16</a:t>
+              <a:t>14 / 18</a:t>
             </a:r>
           </a:p>
         </p:txBody>
@@ -10563,7 +10565,7 @@
                 </a:solidFill>
                 <a:latin typeface="Helvetica Neue"/>
               </a:rPr>
-              <a:t>15 / 16</a:t>
+              <a:t>15 / 18</a:t>
             </a:r>
           </a:p>
         </p:txBody>
@@ -11469,7 +11471,7 @@
                 </a:solidFill>
                 <a:latin typeface="PingFang SC"/>
               </a:rPr>
-              <a:t>证据台账</a:t>
+              <a:t>真实生产使用</a:t>
             </a:r>
           </a:p>
         </p:txBody>
@@ -11511,7 +11513,7 @@
                 </a:solidFill>
                 <a:latin typeface="PingFang SC"/>
               </a:rPr>
-              <a:t>正式录制已闭环；全部证据来自干净录制库</a:t>
+              <a:t>同一个 Skill，在真实生产 Agent 工程里天天在跑</a:t>
             </a:r>
           </a:p>
         </p:txBody>
@@ -11553,7 +11555,7 @@
                 </a:solidFill>
                 <a:latin typeface="PingFang SC"/>
               </a:rPr>
-              <a:t>已证明的事实与尚未证明的边界必须同时出现在结论里。</a:t>
+              <a:t>Claude Code / Codex 按 prompt-regression-governance 驱动真实项目的提示词优化与回归验收。</a:t>
             </a:r>
           </a:p>
         </p:txBody>
@@ -11722,7 +11724,7 @@
                 </a:solidFill>
                 <a:latin typeface="Helvetica Neue"/>
               </a:rPr>
-              <a:t>16 / 16</a:t>
+              <a:t>16 / 18</a:t>
             </a:r>
           </a:p>
         </p:txBody>
@@ -11735,8 +11737,8 @@
         </p:nvSpPr>
         <p:spPr>
           <a:xfrm>
-            <a:off x="713232" y="1847088"/>
-            <a:ext cx="3364992" cy="841248"/>
+            <a:off x="640080" y="1810512"/>
+            <a:ext cx="6620256" cy="3685032"/>
           </a:xfrm>
           <a:prstGeom prst="rect">
             <a:avLst/>
@@ -11772,142 +11774,82 @@
           </a:p>
         </p:txBody>
       </p:sp>
-      <p:sp>
-        <p:nvSpPr>
-          <p:cNvPr id="10" name="TextBox 9"/>
-          <p:cNvSpPr txBox="1"/>
-          <p:nvPr/>
-        </p:nvSpPr>
-        <p:spPr>
-          <a:xfrm>
-            <a:off x="932688" y="1993392"/>
-            <a:ext cx="1234440" cy="201168"/>
-          </a:xfrm>
-          <a:prstGeom prst="rect">
-            <a:avLst/>
-          </a:prstGeom>
-          <a:noFill/>
-        </p:spPr>
-        <p:txBody>
-          <a:bodyPr wrap="square" lIns="0" rIns="0" tIns="0" bIns="0" anchor="t">
-            <a:spAutoFit/>
-          </a:bodyPr>
-          <a:lstStyle/>
-          <a:p>
-            <a:pPr algn="l">
-              <a:lnSpc>
-                <a:spcPct val="108000"/>
-              </a:lnSpc>
-              <a:spcAft>
-                <a:spcPts val="0"/>
-              </a:spcAft>
-            </a:pPr>
-            <a:r>
-              <a:rPr sz="950" b="1">
+      <p:pic>
+        <p:nvPicPr>
+          <p:cNvPr id="10" name="Picture 9" descr="prod-live-01-session.png"/>
+          <p:cNvPicPr>
+            <a:picLocks noChangeAspect="1"/>
+          </p:cNvPicPr>
+          <p:nvPr/>
+        </p:nvPicPr>
+        <p:blipFill>
+          <a:blip r:embed="rId2"/>
+          <a:stretch>
+            <a:fillRect/>
+          </a:stretch>
+        </p:blipFill>
+        <p:spPr>
+          <a:xfrm>
+            <a:off x="658368" y="1828800"/>
+            <a:ext cx="6583680" cy="3648456"/>
+          </a:xfrm>
+          <a:prstGeom prst="rect">
+            <a:avLst/>
+          </a:prstGeom>
+        </p:spPr>
+      </p:pic>
+      <p:sp>
+        <p:nvSpPr>
+          <p:cNvPr id="11" name="TextBox 10"/>
+          <p:cNvSpPr txBox="1"/>
+          <p:nvPr/>
+        </p:nvSpPr>
+        <p:spPr>
+          <a:xfrm>
+            <a:off x="658368" y="5596128"/>
+            <a:ext cx="6583680" cy="219456"/>
+          </a:xfrm>
+          <a:prstGeom prst="rect">
+            <a:avLst/>
+          </a:prstGeom>
+          <a:noFill/>
+        </p:spPr>
+        <p:txBody>
+          <a:bodyPr wrap="square" lIns="0" rIns="0" tIns="0" bIns="0" anchor="t">
+            <a:spAutoFit/>
+          </a:bodyPr>
+          <a:lstStyle/>
+          <a:p>
+            <a:pPr algn="l">
+              <a:lnSpc>
+                <a:spcPct val="108000"/>
+              </a:lnSpc>
+              <a:spcAft>
+                <a:spcPts val="0"/>
+              </a:spcAft>
+            </a:pPr>
+            <a:r>
+              <a:rPr sz="919" b="0">
                 <a:solidFill>
                   <a:srgbClr val="67706B"/>
                 </a:solidFill>
-                <a:latin typeface="PingFang SC"/>
-              </a:rPr>
-              <a:t>Before</a:t>
-            </a:r>
-          </a:p>
-        </p:txBody>
-      </p:sp>
-      <p:sp>
-        <p:nvSpPr>
-          <p:cNvPr id="11" name="TextBox 10"/>
-          <p:cNvSpPr txBox="1"/>
-          <p:nvPr/>
-        </p:nvSpPr>
-        <p:spPr>
-          <a:xfrm>
-            <a:off x="2066543" y="1965960"/>
-            <a:ext cx="960120" cy="274320"/>
-          </a:xfrm>
-          <a:prstGeom prst="rect">
-            <a:avLst/>
-          </a:prstGeom>
-          <a:noFill/>
-        </p:spPr>
-        <p:txBody>
-          <a:bodyPr wrap="square" lIns="0" rIns="0" tIns="0" bIns="0" anchor="t">
-            <a:spAutoFit/>
-          </a:bodyPr>
-          <a:lstStyle/>
-          <a:p>
-            <a:pPr algn="l">
-              <a:lnSpc>
-                <a:spcPct val="108000"/>
-              </a:lnSpc>
-              <a:spcAft>
-                <a:spcPts val="0"/>
-              </a:spcAft>
-            </a:pPr>
-            <a:r>
-              <a:rPr sz="1400" b="1">
-                <a:solidFill>
-                  <a:srgbClr val="C84438"/>
-                </a:solidFill>
-                <a:latin typeface="Helvetica Neue"/>
-              </a:rPr>
-              <a:t>2 / 5</a:t>
-            </a:r>
-          </a:p>
-        </p:txBody>
-      </p:sp>
-      <p:sp>
-        <p:nvSpPr>
-          <p:cNvPr id="12" name="TextBox 11"/>
-          <p:cNvSpPr txBox="1"/>
-          <p:nvPr/>
-        </p:nvSpPr>
-        <p:spPr>
-          <a:xfrm>
-            <a:off x="2953512" y="2002536"/>
-            <a:ext cx="914400" cy="256032"/>
-          </a:xfrm>
-          <a:prstGeom prst="rect">
-            <a:avLst/>
-          </a:prstGeom>
-          <a:noFill/>
-        </p:spPr>
-        <p:txBody>
-          <a:bodyPr wrap="square" lIns="0" rIns="0" tIns="0" bIns="0" anchor="t">
-            <a:spAutoFit/>
-          </a:bodyPr>
-          <a:lstStyle/>
-          <a:p>
-            <a:pPr algn="l">
-              <a:lnSpc>
-                <a:spcPct val="108000"/>
-              </a:lnSpc>
-              <a:spcAft>
-                <a:spcPts val="0"/>
-              </a:spcAft>
-            </a:pPr>
-            <a:r>
-              <a:rPr sz="860" b="0">
-                <a:solidFill>
-                  <a:srgbClr val="67706B"/>
-                </a:solidFill>
-                <a:latin typeface="PingFang SC"/>
-              </a:rPr>
-              <a:t>3 次行为失败</a:t>
-            </a:r>
-          </a:p>
-        </p:txBody>
-      </p:sp>
-      <p:sp>
-        <p:nvSpPr>
-          <p:cNvPr id="13" name="Rectangle 12"/>
+                <a:latin typeface="Menlo"/>
+              </a:rPr>
+              <a:t>goal 模式整段执行：建 PI 档案 → 冻结基线 → 精读能力路由 → 手术级 diff 瘦身</a:t>
+            </a:r>
+          </a:p>
+        </p:txBody>
+      </p:sp>
+      <p:sp>
+        <p:nvSpPr>
+          <p:cNvPr id="12" name="Rectangle 11"/>
           <p:cNvSpPr/>
           <p:nvPr/>
         </p:nvSpPr>
         <p:spPr>
           <a:xfrm>
-            <a:off x="4398264" y="1847088"/>
-            <a:ext cx="3364992" cy="841248"/>
+            <a:off x="7406640" y="1810512"/>
+            <a:ext cx="4078224" cy="2276856"/>
           </a:xfrm>
           <a:prstGeom prst="rect">
             <a:avLst/>
@@ -11943,142 +11885,40 @@
           </a:p>
         </p:txBody>
       </p:sp>
-      <p:sp>
-        <p:nvSpPr>
-          <p:cNvPr id="14" name="TextBox 13"/>
-          <p:cNvSpPr txBox="1"/>
-          <p:nvPr/>
-        </p:nvSpPr>
-        <p:spPr>
-          <a:xfrm>
-            <a:off x="4617720" y="1993392"/>
-            <a:ext cx="1234440" cy="201168"/>
-          </a:xfrm>
-          <a:prstGeom prst="rect">
-            <a:avLst/>
-          </a:prstGeom>
-          <a:noFill/>
-        </p:spPr>
-        <p:txBody>
-          <a:bodyPr wrap="square" lIns="0" rIns="0" tIns="0" bIns="0" anchor="t">
-            <a:spAutoFit/>
-          </a:bodyPr>
-          <a:lstStyle/>
-          <a:p>
-            <a:pPr algn="l">
-              <a:lnSpc>
-                <a:spcPct val="108000"/>
-              </a:lnSpc>
-              <a:spcAft>
-                <a:spcPts val="0"/>
-              </a:spcAft>
-            </a:pPr>
-            <a:r>
-              <a:rPr sz="950" b="1">
-                <a:solidFill>
-                  <a:srgbClr val="67706B"/>
-                </a:solidFill>
-                <a:latin typeface="PingFang SC"/>
-              </a:rPr>
-              <a:t>Headline</a:t>
-            </a:r>
-          </a:p>
-        </p:txBody>
-      </p:sp>
-      <p:sp>
-        <p:nvSpPr>
-          <p:cNvPr id="15" name="TextBox 14"/>
-          <p:cNvSpPr txBox="1"/>
-          <p:nvPr/>
-        </p:nvSpPr>
-        <p:spPr>
-          <a:xfrm>
-            <a:off x="5751576" y="1965960"/>
-            <a:ext cx="960120" cy="274320"/>
-          </a:xfrm>
-          <a:prstGeom prst="rect">
-            <a:avLst/>
-          </a:prstGeom>
-          <a:noFill/>
-        </p:spPr>
-        <p:txBody>
-          <a:bodyPr wrap="square" lIns="0" rIns="0" tIns="0" bIns="0" anchor="t">
-            <a:spAutoFit/>
-          </a:bodyPr>
-          <a:lstStyle/>
-          <a:p>
-            <a:pPr algn="l">
-              <a:lnSpc>
-                <a:spcPct val="108000"/>
-              </a:lnSpc>
-              <a:spcAft>
-                <a:spcPts val="0"/>
-              </a:spcAft>
-            </a:pPr>
-            <a:r>
-              <a:rPr sz="1400" b="1">
-                <a:solidFill>
-                  <a:srgbClr val="17745A"/>
-                </a:solidFill>
-                <a:latin typeface="Helvetica Neue"/>
-              </a:rPr>
-              <a:t>5 / 5</a:t>
-            </a:r>
-          </a:p>
-        </p:txBody>
-      </p:sp>
-      <p:sp>
-        <p:nvSpPr>
-          <p:cNvPr id="16" name="TextBox 15"/>
-          <p:cNvSpPr txBox="1"/>
-          <p:nvPr/>
-        </p:nvSpPr>
-        <p:spPr>
-          <a:xfrm>
-            <a:off x="6638544" y="2002536"/>
-            <a:ext cx="914400" cy="256032"/>
-          </a:xfrm>
-          <a:prstGeom prst="rect">
-            <a:avLst/>
-          </a:prstGeom>
-          <a:noFill/>
-        </p:spPr>
-        <p:txBody>
-          <a:bodyPr wrap="square" lIns="0" rIns="0" tIns="0" bIns="0" anchor="t">
-            <a:spAutoFit/>
-          </a:bodyPr>
-          <a:lstStyle/>
-          <a:p>
-            <a:pPr algn="l">
-              <a:lnSpc>
-                <a:spcPct val="108000"/>
-              </a:lnSpc>
-              <a:spcAft>
-                <a:spcPts val="0"/>
-              </a:spcAft>
-            </a:pPr>
-            <a:r>
-              <a:rPr sz="860" b="0">
-                <a:solidFill>
-                  <a:srgbClr val="67706B"/>
-                </a:solidFill>
-                <a:latin typeface="PingFang SC"/>
-              </a:rPr>
-              <a:t>同 Case + Manifest</a:t>
-            </a:r>
-          </a:p>
-        </p:txBody>
-      </p:sp>
-      <p:sp>
-        <p:nvSpPr>
-          <p:cNvPr id="17" name="Rectangle 16"/>
+      <p:pic>
+        <p:nvPicPr>
+          <p:cNvPr id="13" name="Picture 12" descr="prod-live-02-regression.png"/>
+          <p:cNvPicPr>
+            <a:picLocks noChangeAspect="1"/>
+          </p:cNvPicPr>
+          <p:nvPr/>
+        </p:nvPicPr>
+        <p:blipFill>
+          <a:blip r:embed="rId3"/>
+          <a:stretch>
+            <a:fillRect/>
+          </a:stretch>
+        </p:blipFill>
+        <p:spPr>
+          <a:xfrm>
+            <a:off x="7424927" y="1828800"/>
+            <a:ext cx="4041648" cy="2240280"/>
+          </a:xfrm>
+          <a:prstGeom prst="rect">
+            <a:avLst/>
+          </a:prstGeom>
+        </p:spPr>
+      </p:pic>
+      <p:sp>
+        <p:nvSpPr>
+          <p:cNvPr id="14" name="Rectangle 13"/>
           <p:cNvSpPr/>
           <p:nvPr/>
         </p:nvSpPr>
         <p:spPr>
           <a:xfrm>
-            <a:off x="8083296" y="1847088"/>
-            <a:ext cx="3364992" cy="841248"/>
+            <a:off x="7406640" y="4187952"/>
+            <a:ext cx="4078224" cy="2276856"/>
           </a:xfrm>
           <a:prstGeom prst="rect">
             <a:avLst/>
@@ -12114,142 +11954,445 @@
           </a:p>
         </p:txBody>
       </p:sp>
-      <p:sp>
-        <p:nvSpPr>
-          <p:cNvPr id="18" name="TextBox 17"/>
-          <p:cNvSpPr txBox="1"/>
-          <p:nvPr/>
-        </p:nvSpPr>
-        <p:spPr>
-          <a:xfrm>
-            <a:off x="8302752" y="1993392"/>
-            <a:ext cx="1234440" cy="201168"/>
-          </a:xfrm>
-          <a:prstGeom prst="rect">
-            <a:avLst/>
-          </a:prstGeom>
-          <a:noFill/>
-        </p:spPr>
-        <p:txBody>
-          <a:bodyPr wrap="square" lIns="0" rIns="0" tIns="0" bIns="0" anchor="t">
-            <a:spAutoFit/>
-          </a:bodyPr>
-          <a:lstStyle/>
-          <a:p>
-            <a:pPr algn="l">
-              <a:lnSpc>
-                <a:spcPct val="108000"/>
-              </a:lnSpc>
-              <a:spcAft>
-                <a:spcPts val="0"/>
-              </a:spcAft>
-            </a:pPr>
-            <a:r>
-              <a:rPr sz="950" b="1">
+      <p:pic>
+        <p:nvPicPr>
+          <p:cNvPr id="15" name="Picture 14" descr="prod-live-03-report.png"/>
+          <p:cNvPicPr>
+            <a:picLocks noChangeAspect="1"/>
+          </p:cNvPicPr>
+          <p:nvPr/>
+        </p:nvPicPr>
+        <p:blipFill>
+          <a:blip r:embed="rId4"/>
+          <a:stretch>
+            <a:fillRect/>
+          </a:stretch>
+        </p:blipFill>
+        <p:spPr>
+          <a:xfrm>
+            <a:off x="7424927" y="4206240"/>
+            <a:ext cx="4041648" cy="2240280"/>
+          </a:xfrm>
+          <a:prstGeom prst="rect">
+            <a:avLst/>
+          </a:prstGeom>
+        </p:spPr>
+      </p:pic>
+      <p:sp>
+        <p:nvSpPr>
+          <p:cNvPr id="16" name="TextBox 15"/>
+          <p:cNvSpPr txBox="1"/>
+          <p:nvPr/>
+        </p:nvSpPr>
+        <p:spPr>
+          <a:xfrm>
+            <a:off x="7424927" y="4078224"/>
+            <a:ext cx="4041648" cy="182880"/>
+          </a:xfrm>
+          <a:prstGeom prst="rect">
+            <a:avLst/>
+          </a:prstGeom>
+          <a:noFill/>
+        </p:spPr>
+        <p:txBody>
+          <a:bodyPr wrap="square" lIns="0" rIns="0" tIns="0" bIns="0" anchor="t">
+            <a:spAutoFit/>
+          </a:bodyPr>
+          <a:lstStyle/>
+          <a:p>
+            <a:pPr algn="l">
+              <a:lnSpc>
+                <a:spcPct val="108000"/>
+              </a:lnSpc>
+              <a:spcAft>
+                <a:spcPts val="0"/>
+              </a:spcAft>
+            </a:pPr>
+            <a:r>
+              <a:rPr sz="819" b="0">
                 <a:solidFill>
                   <a:srgbClr val="67706B"/>
                 </a:solidFill>
                 <a:latin typeface="PingFang SC"/>
               </a:rPr>
-              <a:t>Matrix</a:t>
-            </a:r>
-          </a:p>
-        </p:txBody>
-      </p:sp>
-      <p:sp>
-        <p:nvSpPr>
-          <p:cNvPr id="19" name="TextBox 18"/>
-          <p:cNvSpPr txBox="1"/>
-          <p:nvPr/>
-        </p:nvSpPr>
-        <p:spPr>
-          <a:xfrm>
-            <a:off x="9436608" y="1965960"/>
-            <a:ext cx="960120" cy="274320"/>
-          </a:xfrm>
-          <a:prstGeom prst="rect">
-            <a:avLst/>
-          </a:prstGeom>
-          <a:noFill/>
-        </p:spPr>
-        <p:txBody>
-          <a:bodyPr wrap="square" lIns="0" rIns="0" tIns="0" bIns="0" anchor="t">
-            <a:spAutoFit/>
-          </a:bodyPr>
-          <a:lstStyle/>
-          <a:p>
-            <a:pPr algn="l">
-              <a:lnSpc>
-                <a:spcPct val="108000"/>
-              </a:lnSpc>
-              <a:spcAft>
-                <a:spcPts val="0"/>
-              </a:spcAft>
-            </a:pPr>
-            <a:r>
-              <a:rPr sz="1400" b="1">
-                <a:solidFill>
-                  <a:srgbClr val="17745A"/>
+              <a:t>哨兵异常 → 归因 → 修用例/修输入</a:t>
+            </a:r>
+          </a:p>
+        </p:txBody>
+      </p:sp>
+      <p:sp>
+        <p:nvSpPr>
+          <p:cNvPr id="17" name="TextBox 16"/>
+          <p:cNvSpPr txBox="1"/>
+          <p:nvPr/>
+        </p:nvSpPr>
+        <p:spPr>
+          <a:xfrm>
+            <a:off x="7424927" y="6483096"/>
+            <a:ext cx="4041648" cy="182880"/>
+          </a:xfrm>
+          <a:prstGeom prst="rect">
+            <a:avLst/>
+          </a:prstGeom>
+          <a:noFill/>
+        </p:spPr>
+        <p:txBody>
+          <a:bodyPr wrap="square" lIns="0" rIns="0" tIns="0" bIns="0" anchor="t">
+            <a:spAutoFit/>
+          </a:bodyPr>
+          <a:lstStyle/>
+          <a:p>
+            <a:pPr algn="l">
+              <a:lnSpc>
+                <a:spcPct val="108000"/>
+              </a:lnSpc>
+              <a:spcAft>
+                <a:spcPts val="0"/>
+              </a:spcAft>
+            </a:pPr>
+            <a:r>
+              <a:rPr sz="819" b="0">
+                <a:solidFill>
+                  <a:srgbClr val="67706B"/>
+                </a:solidFill>
+                <a:latin typeface="PingFang SC"/>
+              </a:rPr>
+              <a:t>v4 终态:四表面 −16%,硬例 20/20</a:t>
+            </a:r>
+          </a:p>
+        </p:txBody>
+      </p:sp>
+    </p:spTree>
+  </p:cSld>
+  <p:clrMapOvr>
+    <a:masterClrMapping/>
+  </p:clrMapOvr>
+</p:sld>
+</file>
+
+<file path=ppt/slides/slide17.xml><?xml version="1.0" encoding="utf-8"?>
+<p:sld xmlns:a="http://schemas.openxmlformats.org/drawingml/2006/main" xmlns:p="http://schemas.openxmlformats.org/presentationml/2006/main" xmlns:r="http://schemas.openxmlformats.org/officeDocument/2006/relationships">
+  <p:cSld>
+    <p:bg>
+      <p:bgPr>
+        <a:solidFill>
+          <a:srgbClr val="F7F6F2"/>
+        </a:solidFill>
+        <a:effectLst/>
+      </p:bgPr>
+    </p:bg>
+    <p:spTree>
+      <p:nvGrpSpPr>
+        <p:cNvPr id="1" name=""/>
+        <p:cNvGrpSpPr/>
+        <p:nvPr/>
+      </p:nvGrpSpPr>
+      <p:grpSpPr/>
+      <p:sp>
+        <p:nvSpPr>
+          <p:cNvPr id="2" name="TextBox 1"/>
+          <p:cNvSpPr txBox="1"/>
+          <p:nvPr/>
+        </p:nvSpPr>
+        <p:spPr>
+          <a:xfrm>
+            <a:off x="658368" y="310896"/>
+            <a:ext cx="4754880" cy="182880"/>
+          </a:xfrm>
+          <a:prstGeom prst="rect">
+            <a:avLst/>
+          </a:prstGeom>
+          <a:noFill/>
+        </p:spPr>
+        <p:txBody>
+          <a:bodyPr wrap="square" lIns="0" rIns="0" tIns="0" bIns="0" anchor="t">
+            <a:spAutoFit/>
+          </a:bodyPr>
+          <a:lstStyle/>
+          <a:p>
+            <a:pPr algn="l">
+              <a:lnSpc>
+                <a:spcPct val="108000"/>
+              </a:lnSpc>
+              <a:spcAft>
+                <a:spcPts val="0"/>
+              </a:spcAft>
+            </a:pPr>
+            <a:r>
+              <a:rPr sz="850" b="1">
+                <a:solidFill>
+                  <a:srgbClr val="285CF5"/>
+                </a:solidFill>
+                <a:latin typeface="PingFang SC"/>
+              </a:rPr>
+              <a:t>生产级验收</a:t>
+            </a:r>
+          </a:p>
+        </p:txBody>
+      </p:sp>
+      <p:sp>
+        <p:nvSpPr>
+          <p:cNvPr id="3" name="TextBox 2"/>
+          <p:cNvSpPr txBox="1"/>
+          <p:nvPr/>
+        </p:nvSpPr>
+        <p:spPr>
+          <a:xfrm>
+            <a:off x="658368" y="649224"/>
+            <a:ext cx="10424160" cy="457200"/>
+          </a:xfrm>
+          <a:prstGeom prst="rect">
+            <a:avLst/>
+          </a:prstGeom>
+          <a:noFill/>
+        </p:spPr>
+        <p:txBody>
+          <a:bodyPr wrap="square" lIns="0" rIns="0" tIns="0" bIns="0" anchor="t">
+            <a:spAutoFit/>
+          </a:bodyPr>
+          <a:lstStyle/>
+          <a:p>
+            <a:pPr algn="l">
+              <a:lnSpc>
+                <a:spcPct val="108000"/>
+              </a:lnSpc>
+              <a:spcAft>
+                <a:spcPts val="0"/>
+              </a:spcAft>
+            </a:pPr>
+            <a:r>
+              <a:rPr sz="2700" b="1">
+                <a:solidFill>
+                  <a:srgbClr val="121617"/>
+                </a:solidFill>
+                <a:latin typeface="PingFang SC"/>
+              </a:rPr>
+              <a:t>生产项目的 PI 验收报告：实证迭代、如实披露</a:t>
+            </a:r>
+          </a:p>
+        </p:txBody>
+      </p:sp>
+      <p:sp>
+        <p:nvSpPr>
+          <p:cNvPr id="4" name="TextBox 3"/>
+          <p:cNvSpPr txBox="1"/>
+          <p:nvPr/>
+        </p:nvSpPr>
+        <p:spPr>
+          <a:xfrm>
+            <a:off x="676656" y="1161288"/>
+            <a:ext cx="10515600" cy="228600"/>
+          </a:xfrm>
+          <a:prstGeom prst="rect">
+            <a:avLst/>
+          </a:prstGeom>
+          <a:noFill/>
+        </p:spPr>
+        <p:txBody>
+          <a:bodyPr wrap="square" lIns="0" rIns="0" tIns="0" bIns="0" anchor="t">
+            <a:spAutoFit/>
+          </a:bodyPr>
+          <a:lstStyle/>
+          <a:p>
+            <a:pPr algn="l">
+              <a:lnSpc>
+                <a:spcPct val="108000"/>
+              </a:lnSpc>
+              <a:spcAft>
+                <a:spcPts val="0"/>
+              </a:spcAft>
+            </a:pPr>
+            <a:r>
+              <a:rPr sz="1019" b="0">
+                <a:solidFill>
+                  <a:srgbClr val="67706B"/>
+                </a:solidFill>
+                <a:latin typeface="PingFang SC"/>
+              </a:rPr>
+              <a:t>55 Cell 矩阵、2064 项单测基线、v1→v4 四轮输入修正与 before 归因闭环。</a:t>
+            </a:r>
+          </a:p>
+        </p:txBody>
+      </p:sp>
+      <p:sp>
+        <p:nvSpPr>
+          <p:cNvPr id="5" name="TextBox 4"/>
+          <p:cNvSpPr txBox="1"/>
+          <p:nvPr/>
+        </p:nvSpPr>
+        <p:spPr>
+          <a:xfrm>
+            <a:off x="11018520" y="338328"/>
+            <a:ext cx="502920" cy="182880"/>
+          </a:xfrm>
+          <a:prstGeom prst="rect">
+            <a:avLst/>
+          </a:prstGeom>
+          <a:noFill/>
+        </p:spPr>
+        <p:txBody>
+          <a:bodyPr wrap="square" lIns="0" rIns="0" tIns="0" bIns="0" anchor="t">
+            <a:spAutoFit/>
+          </a:bodyPr>
+          <a:lstStyle/>
+          <a:p>
+            <a:pPr algn="r">
+              <a:lnSpc>
+                <a:spcPct val="108000"/>
+              </a:lnSpc>
+              <a:spcAft>
+                <a:spcPts val="0"/>
+              </a:spcAft>
+            </a:pPr>
+            <a:r>
+              <a:rPr sz="900" b="1">
+                <a:solidFill>
+                  <a:srgbClr val="929A95"/>
                 </a:solidFill>
                 <a:latin typeface="Helvetica Neue"/>
               </a:rPr>
-              <a:t>30 / 30</a:t>
-            </a:r>
-          </a:p>
-        </p:txBody>
-      </p:sp>
-      <p:sp>
-        <p:nvSpPr>
-          <p:cNvPr id="20" name="TextBox 19"/>
-          <p:cNvSpPr txBox="1"/>
-          <p:nvPr/>
-        </p:nvSpPr>
-        <p:spPr>
-          <a:xfrm>
-            <a:off x="10323576" y="2002536"/>
-            <a:ext cx="914400" cy="256032"/>
-          </a:xfrm>
-          <a:prstGeom prst="rect">
-            <a:avLst/>
-          </a:prstGeom>
-          <a:noFill/>
-        </p:spPr>
-        <p:txBody>
-          <a:bodyPr wrap="square" lIns="0" rIns="0" tIns="0" bIns="0" anchor="t">
-            <a:spAutoFit/>
-          </a:bodyPr>
-          <a:lstStyle/>
-          <a:p>
-            <a:pPr algn="l">
-              <a:lnSpc>
-                <a:spcPct val="108000"/>
-              </a:lnSpc>
-              <a:spcAft>
-                <a:spcPts val="0"/>
-              </a:spcAft>
-            </a:pPr>
-            <a:r>
-              <a:rPr sz="860" b="0">
-                <a:solidFill>
-                  <a:srgbClr val="67706B"/>
-                </a:solidFill>
-                <a:latin typeface="PingFang SC"/>
-              </a:rPr>
-              <a:t>6 Cells</a:t>
-            </a:r>
-          </a:p>
-        </p:txBody>
-      </p:sp>
-      <p:sp>
-        <p:nvSpPr>
-          <p:cNvPr id="21" name="Rectangle 20"/>
+              <a:t>17</a:t>
+            </a:r>
+          </a:p>
+        </p:txBody>
+      </p:sp>
+      <p:sp>
+        <p:nvSpPr>
+          <p:cNvPr id="6" name="Rectangle 5"/>
           <p:cNvSpPr/>
           <p:nvPr/>
         </p:nvSpPr>
         <p:spPr>
           <a:xfrm>
-            <a:off x="713232" y="2898648"/>
-            <a:ext cx="3364992" cy="841248"/>
+            <a:off x="658368" y="1527048"/>
+            <a:ext cx="10881360" cy="10972"/>
+          </a:xfrm>
+          <a:prstGeom prst="rect">
+            <a:avLst/>
+          </a:prstGeom>
+          <a:solidFill>
+            <a:srgbClr val="D8DDD9"/>
+          </a:solidFill>
+          <a:ln>
+            <a:noFill/>
+          </a:ln>
+        </p:spPr>
+        <p:style>
+          <a:lnRef idx="1">
+            <a:schemeClr val="accent1"/>
+          </a:lnRef>
+          <a:fillRef idx="3">
+            <a:schemeClr val="accent1"/>
+          </a:fillRef>
+          <a:effectRef idx="2">
+            <a:schemeClr val="accent1"/>
+          </a:effectRef>
+          <a:fontRef idx="minor">
+            <a:schemeClr val="lt1"/>
+          </a:fontRef>
+        </p:style>
+        <p:txBody>
+          <a:bodyPr rtlCol="0" anchor="ctr"/>
+          <a:lstStyle/>
+          <a:p>
+            <a:pPr algn="ctr"/>
+          </a:p>
+        </p:txBody>
+      </p:sp>
+      <p:sp>
+        <p:nvSpPr>
+          <p:cNvPr id="7" name="TextBox 6"/>
+          <p:cNvSpPr txBox="1"/>
+          <p:nvPr/>
+        </p:nvSpPr>
+        <p:spPr>
+          <a:xfrm>
+            <a:off x="658368" y="6556248"/>
+            <a:ext cx="3200400" cy="137160"/>
+          </a:xfrm>
+          <a:prstGeom prst="rect">
+            <a:avLst/>
+          </a:prstGeom>
+          <a:noFill/>
+        </p:spPr>
+        <p:txBody>
+          <a:bodyPr wrap="square" lIns="0" rIns="0" tIns="0" bIns="0" anchor="t">
+            <a:spAutoFit/>
+          </a:bodyPr>
+          <a:lstStyle/>
+          <a:p>
+            <a:pPr algn="l">
+              <a:lnSpc>
+                <a:spcPct val="108000"/>
+              </a:lnSpc>
+              <a:spcAft>
+                <a:spcPts val="0"/>
+              </a:spcAft>
+            </a:pPr>
+            <a:r>
+              <a:rPr sz="700" b="0">
+                <a:solidFill>
+                  <a:srgbClr val="929A95"/>
+                </a:solidFill>
+                <a:latin typeface="PingFang SC"/>
+              </a:rPr>
+              <a:t>AgentRig · GOAI 2026 · REVIEW</a:t>
+            </a:r>
+          </a:p>
+        </p:txBody>
+      </p:sp>
+      <p:sp>
+        <p:nvSpPr>
+          <p:cNvPr id="8" name="TextBox 7"/>
+          <p:cNvSpPr txBox="1"/>
+          <p:nvPr/>
+        </p:nvSpPr>
+        <p:spPr>
+          <a:xfrm>
+            <a:off x="10652760" y="6556248"/>
+            <a:ext cx="877824" cy="137160"/>
+          </a:xfrm>
+          <a:prstGeom prst="rect">
+            <a:avLst/>
+          </a:prstGeom>
+          <a:noFill/>
+        </p:spPr>
+        <p:txBody>
+          <a:bodyPr wrap="square" lIns="0" rIns="0" tIns="0" bIns="0" anchor="t">
+            <a:spAutoFit/>
+          </a:bodyPr>
+          <a:lstStyle/>
+          <a:p>
+            <a:pPr algn="r">
+              <a:lnSpc>
+                <a:spcPct val="108000"/>
+              </a:lnSpc>
+              <a:spcAft>
+                <a:spcPts val="0"/>
+              </a:spcAft>
+            </a:pPr>
+            <a:r>
+              <a:rPr sz="700" b="0">
+                <a:solidFill>
+                  <a:srgbClr val="929A95"/>
+                </a:solidFill>
+                <a:latin typeface="Helvetica Neue"/>
+              </a:rPr>
+              <a:t>17 / 18</a:t>
+            </a:r>
+          </a:p>
+        </p:txBody>
+      </p:sp>
+      <p:sp>
+        <p:nvSpPr>
+          <p:cNvPr id="9" name="Rectangle 8"/>
+          <p:cNvSpPr/>
+          <p:nvPr/>
+        </p:nvSpPr>
+        <p:spPr>
+          <a:xfrm>
+            <a:off x="1335024" y="1828800"/>
+            <a:ext cx="9500615" cy="4261104"/>
           </a:xfrm>
           <a:prstGeom prst="rect">
             <a:avLst/>
@@ -12285,141 +12428,402 @@
           </a:p>
         </p:txBody>
       </p:sp>
-      <p:sp>
-        <p:nvSpPr>
-          <p:cNvPr id="22" name="TextBox 21"/>
-          <p:cNvSpPr txBox="1"/>
-          <p:nvPr/>
-        </p:nvSpPr>
-        <p:spPr>
-          <a:xfrm>
-            <a:off x="932688" y="3044952"/>
-            <a:ext cx="1234440" cy="201168"/>
-          </a:xfrm>
-          <a:prstGeom prst="rect">
-            <a:avLst/>
-          </a:prstGeom>
-          <a:noFill/>
-        </p:spPr>
-        <p:txBody>
-          <a:bodyPr wrap="square" lIns="0" rIns="0" tIns="0" bIns="0" anchor="t">
-            <a:spAutoFit/>
-          </a:bodyPr>
-          <a:lstStyle/>
-          <a:p>
-            <a:pPr algn="l">
-              <a:lnSpc>
-                <a:spcPct val="108000"/>
-              </a:lnSpc>
-              <a:spcAft>
-                <a:spcPts val="0"/>
-              </a:spcAft>
-            </a:pPr>
-            <a:r>
-              <a:rPr sz="950" b="1">
+      <p:pic>
+        <p:nvPicPr>
+          <p:cNvPr id="10" name="Picture 9" descr="prod-pi-report.png"/>
+          <p:cNvPicPr>
+            <a:picLocks noChangeAspect="1"/>
+          </p:cNvPicPr>
+          <p:nvPr/>
+        </p:nvPicPr>
+        <p:blipFill>
+          <a:blip r:embed="rId2"/>
+          <a:stretch>
+            <a:fillRect/>
+          </a:stretch>
+        </p:blipFill>
+        <p:spPr>
+          <a:xfrm>
+            <a:off x="1353312" y="1847088"/>
+            <a:ext cx="9464040" cy="4224528"/>
+          </a:xfrm>
+          <a:prstGeom prst="rect">
+            <a:avLst/>
+          </a:prstGeom>
+        </p:spPr>
+      </p:pic>
+      <p:sp>
+        <p:nvSpPr>
+          <p:cNvPr id="11" name="TextBox 10"/>
+          <p:cNvSpPr txBox="1"/>
+          <p:nvPr/>
+        </p:nvSpPr>
+        <p:spPr>
+          <a:xfrm>
+            <a:off x="1353312" y="6236208"/>
+            <a:ext cx="9464040" cy="219456"/>
+          </a:xfrm>
+          <a:prstGeom prst="rect">
+            <a:avLst/>
+          </a:prstGeom>
+          <a:noFill/>
+        </p:spPr>
+        <p:txBody>
+          <a:bodyPr wrap="square" lIns="0" rIns="0" tIns="0" bIns="0" anchor="t">
+            <a:spAutoFit/>
+          </a:bodyPr>
+          <a:lstStyle/>
+          <a:p>
+            <a:pPr algn="ctr">
+              <a:lnSpc>
+                <a:spcPct val="108000"/>
+              </a:lnSpc>
+              <a:spcAft>
+                <a:spcPts val="0"/>
+              </a:spcAft>
+            </a:pPr>
+            <a:r>
+              <a:rPr sz="919" b="0">
                 <a:solidFill>
                   <a:srgbClr val="67706B"/>
                 </a:solidFill>
-                <a:latin typeface="PingFang SC"/>
-              </a:rPr>
-              <a:t>Sample replay</a:t>
-            </a:r>
-          </a:p>
-        </p:txBody>
-      </p:sp>
-      <p:sp>
-        <p:nvSpPr>
-          <p:cNvPr id="23" name="TextBox 22"/>
-          <p:cNvSpPr txBox="1"/>
-          <p:nvPr/>
-        </p:nvSpPr>
-        <p:spPr>
-          <a:xfrm>
-            <a:off x="2066543" y="3017520"/>
-            <a:ext cx="960120" cy="274320"/>
-          </a:xfrm>
-          <a:prstGeom prst="rect">
-            <a:avLst/>
-          </a:prstGeom>
-          <a:noFill/>
-        </p:spPr>
-        <p:txBody>
-          <a:bodyPr wrap="square" lIns="0" rIns="0" tIns="0" bIns="0" anchor="t">
-            <a:spAutoFit/>
-          </a:bodyPr>
-          <a:lstStyle/>
-          <a:p>
-            <a:pPr algn="l">
-              <a:lnSpc>
-                <a:spcPct val="108000"/>
-              </a:lnSpc>
-              <a:spcAft>
-                <a:spcPts val="0"/>
-              </a:spcAft>
-            </a:pPr>
-            <a:r>
-              <a:rPr sz="1400" b="1">
-                <a:solidFill>
-                  <a:srgbClr val="17745A"/>
+                <a:latin typeface="Menlo"/>
+              </a:rPr>
+              <a:t>docs/prompt-iterations/…/PI-20260815-01 · decision: ACCEPT（带披露） · 硬性规则 20/20 · 语义 43 Cell 干净 + 1 Cell 4/5 披露</a:t>
+            </a:r>
+          </a:p>
+        </p:txBody>
+      </p:sp>
+    </p:spTree>
+  </p:cSld>
+  <p:clrMapOvr>
+    <a:masterClrMapping/>
+  </p:clrMapOvr>
+</p:sld>
+</file>
+
+<file path=ppt/slides/slide18.xml><?xml version="1.0" encoding="utf-8"?>
+<p:sld xmlns:a="http://schemas.openxmlformats.org/drawingml/2006/main" xmlns:p="http://schemas.openxmlformats.org/presentationml/2006/main" xmlns:r="http://schemas.openxmlformats.org/officeDocument/2006/relationships">
+  <p:cSld>
+    <p:bg>
+      <p:bgPr>
+        <a:solidFill>
+          <a:srgbClr val="F7F6F2"/>
+        </a:solidFill>
+        <a:effectLst/>
+      </p:bgPr>
+    </p:bg>
+    <p:spTree>
+      <p:nvGrpSpPr>
+        <p:cNvPr id="1" name=""/>
+        <p:cNvGrpSpPr/>
+        <p:nvPr/>
+      </p:nvGrpSpPr>
+      <p:grpSpPr/>
+      <p:sp>
+        <p:nvSpPr>
+          <p:cNvPr id="2" name="TextBox 1"/>
+          <p:cNvSpPr txBox="1"/>
+          <p:nvPr/>
+        </p:nvSpPr>
+        <p:spPr>
+          <a:xfrm>
+            <a:off x="658368" y="310896"/>
+            <a:ext cx="4754880" cy="182880"/>
+          </a:xfrm>
+          <a:prstGeom prst="rect">
+            <a:avLst/>
+          </a:prstGeom>
+          <a:noFill/>
+        </p:spPr>
+        <p:txBody>
+          <a:bodyPr wrap="square" lIns="0" rIns="0" tIns="0" bIns="0" anchor="t">
+            <a:spAutoFit/>
+          </a:bodyPr>
+          <a:lstStyle/>
+          <a:p>
+            <a:pPr algn="l">
+              <a:lnSpc>
+                <a:spcPct val="108000"/>
+              </a:lnSpc>
+              <a:spcAft>
+                <a:spcPts val="0"/>
+              </a:spcAft>
+            </a:pPr>
+            <a:r>
+              <a:rPr sz="850" b="1">
+                <a:solidFill>
+                  <a:srgbClr val="285CF5"/>
+                </a:solidFill>
+                <a:latin typeface="PingFang SC"/>
+              </a:rPr>
+              <a:t>证据台账</a:t>
+            </a:r>
+          </a:p>
+        </p:txBody>
+      </p:sp>
+      <p:sp>
+        <p:nvSpPr>
+          <p:cNvPr id="3" name="TextBox 2"/>
+          <p:cNvSpPr txBox="1"/>
+          <p:nvPr/>
+        </p:nvSpPr>
+        <p:spPr>
+          <a:xfrm>
+            <a:off x="658368" y="649224"/>
+            <a:ext cx="10424160" cy="457200"/>
+          </a:xfrm>
+          <a:prstGeom prst="rect">
+            <a:avLst/>
+          </a:prstGeom>
+          <a:noFill/>
+        </p:spPr>
+        <p:txBody>
+          <a:bodyPr wrap="square" lIns="0" rIns="0" tIns="0" bIns="0" anchor="t">
+            <a:spAutoFit/>
+          </a:bodyPr>
+          <a:lstStyle/>
+          <a:p>
+            <a:pPr algn="l">
+              <a:lnSpc>
+                <a:spcPct val="108000"/>
+              </a:lnSpc>
+              <a:spcAft>
+                <a:spcPts val="0"/>
+              </a:spcAft>
+            </a:pPr>
+            <a:r>
+              <a:rPr sz="2700" b="1">
+                <a:solidFill>
+                  <a:srgbClr val="121617"/>
+                </a:solidFill>
+                <a:latin typeface="PingFang SC"/>
+              </a:rPr>
+              <a:t>正式录制已闭环；全部证据来自干净录制库</a:t>
+            </a:r>
+          </a:p>
+        </p:txBody>
+      </p:sp>
+      <p:sp>
+        <p:nvSpPr>
+          <p:cNvPr id="4" name="TextBox 3"/>
+          <p:cNvSpPr txBox="1"/>
+          <p:nvPr/>
+        </p:nvSpPr>
+        <p:spPr>
+          <a:xfrm>
+            <a:off x="676656" y="1161288"/>
+            <a:ext cx="10515600" cy="228600"/>
+          </a:xfrm>
+          <a:prstGeom prst="rect">
+            <a:avLst/>
+          </a:prstGeom>
+          <a:noFill/>
+        </p:spPr>
+        <p:txBody>
+          <a:bodyPr wrap="square" lIns="0" rIns="0" tIns="0" bIns="0" anchor="t">
+            <a:spAutoFit/>
+          </a:bodyPr>
+          <a:lstStyle/>
+          <a:p>
+            <a:pPr algn="l">
+              <a:lnSpc>
+                <a:spcPct val="108000"/>
+              </a:lnSpc>
+              <a:spcAft>
+                <a:spcPts val="0"/>
+              </a:spcAft>
+            </a:pPr>
+            <a:r>
+              <a:rPr sz="1019" b="0">
+                <a:solidFill>
+                  <a:srgbClr val="67706B"/>
+                </a:solidFill>
+                <a:latin typeface="PingFang SC"/>
+              </a:rPr>
+              <a:t>已证明的事实与尚未证明的边界必须同时出现在结论里。</a:t>
+            </a:r>
+          </a:p>
+        </p:txBody>
+      </p:sp>
+      <p:sp>
+        <p:nvSpPr>
+          <p:cNvPr id="5" name="TextBox 4"/>
+          <p:cNvSpPr txBox="1"/>
+          <p:nvPr/>
+        </p:nvSpPr>
+        <p:spPr>
+          <a:xfrm>
+            <a:off x="11018520" y="338328"/>
+            <a:ext cx="502920" cy="182880"/>
+          </a:xfrm>
+          <a:prstGeom prst="rect">
+            <a:avLst/>
+          </a:prstGeom>
+          <a:noFill/>
+        </p:spPr>
+        <p:txBody>
+          <a:bodyPr wrap="square" lIns="0" rIns="0" tIns="0" bIns="0" anchor="t">
+            <a:spAutoFit/>
+          </a:bodyPr>
+          <a:lstStyle/>
+          <a:p>
+            <a:pPr algn="r">
+              <a:lnSpc>
+                <a:spcPct val="108000"/>
+              </a:lnSpc>
+              <a:spcAft>
+                <a:spcPts val="0"/>
+              </a:spcAft>
+            </a:pPr>
+            <a:r>
+              <a:rPr sz="900" b="1">
+                <a:solidFill>
+                  <a:srgbClr val="929A95"/>
                 </a:solidFill>
                 <a:latin typeface="Helvetica Neue"/>
               </a:rPr>
-              <a:t>5 / 5</a:t>
-            </a:r>
-          </a:p>
-        </p:txBody>
-      </p:sp>
-      <p:sp>
-        <p:nvSpPr>
-          <p:cNvPr id="24" name="TextBox 23"/>
-          <p:cNvSpPr txBox="1"/>
-          <p:nvPr/>
-        </p:nvSpPr>
-        <p:spPr>
-          <a:xfrm>
-            <a:off x="2953512" y="3054096"/>
-            <a:ext cx="914400" cy="256032"/>
-          </a:xfrm>
-          <a:prstGeom prst="rect">
-            <a:avLst/>
-          </a:prstGeom>
-          <a:noFill/>
-        </p:spPr>
-        <p:txBody>
-          <a:bodyPr wrap="square" lIns="0" rIns="0" tIns="0" bIns="0" anchor="t">
-            <a:spAutoFit/>
-          </a:bodyPr>
-          <a:lstStyle/>
-          <a:p>
-            <a:pPr algn="l">
-              <a:lnSpc>
-                <a:spcPct val="108000"/>
-              </a:lnSpc>
-              <a:spcAft>
-                <a:spcPts val="0"/>
-              </a:spcAft>
-            </a:pPr>
-            <a:r>
-              <a:rPr sz="860" b="0">
-                <a:solidFill>
-                  <a:srgbClr val="67706B"/>
-                </a:solidFill>
-                <a:latin typeface="PingFang SC"/>
-              </a:rPr>
-              <a:t>0 real_tool</a:t>
-            </a:r>
-          </a:p>
-        </p:txBody>
-      </p:sp>
-      <p:sp>
-        <p:nvSpPr>
-          <p:cNvPr id="25" name="Rectangle 24"/>
+              <a:t>18</a:t>
+            </a:r>
+          </a:p>
+        </p:txBody>
+      </p:sp>
+      <p:sp>
+        <p:nvSpPr>
+          <p:cNvPr id="6" name="Rectangle 5"/>
           <p:cNvSpPr/>
           <p:nvPr/>
         </p:nvSpPr>
         <p:spPr>
           <a:xfrm>
-            <a:off x="4398264" y="2898648"/>
+            <a:off x="658368" y="1527048"/>
+            <a:ext cx="10881360" cy="10972"/>
+          </a:xfrm>
+          <a:prstGeom prst="rect">
+            <a:avLst/>
+          </a:prstGeom>
+          <a:solidFill>
+            <a:srgbClr val="D8DDD9"/>
+          </a:solidFill>
+          <a:ln>
+            <a:noFill/>
+          </a:ln>
+        </p:spPr>
+        <p:style>
+          <a:lnRef idx="1">
+            <a:schemeClr val="accent1"/>
+          </a:lnRef>
+          <a:fillRef idx="3">
+            <a:schemeClr val="accent1"/>
+          </a:fillRef>
+          <a:effectRef idx="2">
+            <a:schemeClr val="accent1"/>
+          </a:effectRef>
+          <a:fontRef idx="minor">
+            <a:schemeClr val="lt1"/>
+          </a:fontRef>
+        </p:style>
+        <p:txBody>
+          <a:bodyPr rtlCol="0" anchor="ctr"/>
+          <a:lstStyle/>
+          <a:p>
+            <a:pPr algn="ctr"/>
+          </a:p>
+        </p:txBody>
+      </p:sp>
+      <p:sp>
+        <p:nvSpPr>
+          <p:cNvPr id="7" name="TextBox 6"/>
+          <p:cNvSpPr txBox="1"/>
+          <p:nvPr/>
+        </p:nvSpPr>
+        <p:spPr>
+          <a:xfrm>
+            <a:off x="658368" y="6556248"/>
+            <a:ext cx="3200400" cy="137160"/>
+          </a:xfrm>
+          <a:prstGeom prst="rect">
+            <a:avLst/>
+          </a:prstGeom>
+          <a:noFill/>
+        </p:spPr>
+        <p:txBody>
+          <a:bodyPr wrap="square" lIns="0" rIns="0" tIns="0" bIns="0" anchor="t">
+            <a:spAutoFit/>
+          </a:bodyPr>
+          <a:lstStyle/>
+          <a:p>
+            <a:pPr algn="l">
+              <a:lnSpc>
+                <a:spcPct val="108000"/>
+              </a:lnSpc>
+              <a:spcAft>
+                <a:spcPts val="0"/>
+              </a:spcAft>
+            </a:pPr>
+            <a:r>
+              <a:rPr sz="700" b="0">
+                <a:solidFill>
+                  <a:srgbClr val="929A95"/>
+                </a:solidFill>
+                <a:latin typeface="PingFang SC"/>
+              </a:rPr>
+              <a:t>AgentRig · GOAI 2026 · REVIEW</a:t>
+            </a:r>
+          </a:p>
+        </p:txBody>
+      </p:sp>
+      <p:sp>
+        <p:nvSpPr>
+          <p:cNvPr id="8" name="TextBox 7"/>
+          <p:cNvSpPr txBox="1"/>
+          <p:nvPr/>
+        </p:nvSpPr>
+        <p:spPr>
+          <a:xfrm>
+            <a:off x="10652760" y="6556248"/>
+            <a:ext cx="877824" cy="137160"/>
+          </a:xfrm>
+          <a:prstGeom prst="rect">
+            <a:avLst/>
+          </a:prstGeom>
+          <a:noFill/>
+        </p:spPr>
+        <p:txBody>
+          <a:bodyPr wrap="square" lIns="0" rIns="0" tIns="0" bIns="0" anchor="t">
+            <a:spAutoFit/>
+          </a:bodyPr>
+          <a:lstStyle/>
+          <a:p>
+            <a:pPr algn="r">
+              <a:lnSpc>
+                <a:spcPct val="108000"/>
+              </a:lnSpc>
+              <a:spcAft>
+                <a:spcPts val="0"/>
+              </a:spcAft>
+            </a:pPr>
+            <a:r>
+              <a:rPr sz="700" b="0">
+                <a:solidFill>
+                  <a:srgbClr val="929A95"/>
+                </a:solidFill>
+                <a:latin typeface="Helvetica Neue"/>
+              </a:rPr>
+              <a:t>18 / 18</a:t>
+            </a:r>
+          </a:p>
+        </p:txBody>
+      </p:sp>
+      <p:sp>
+        <p:nvSpPr>
+          <p:cNvPr id="9" name="Rectangle 8"/>
+          <p:cNvSpPr/>
+          <p:nvPr/>
+        </p:nvSpPr>
+        <p:spPr>
+          <a:xfrm>
+            <a:off x="713232" y="1847088"/>
             <a:ext cx="3364992" cy="841248"/>
           </a:xfrm>
           <a:prstGeom prst="rect">
@@ -12458,13 +12862,13 @@
       </p:sp>
       <p:sp>
         <p:nvSpPr>
-          <p:cNvPr id="26" name="TextBox 25"/>
-          <p:cNvSpPr txBox="1"/>
-          <p:nvPr/>
-        </p:nvSpPr>
-        <p:spPr>
-          <a:xfrm>
-            <a:off x="4617720" y="3044952"/>
+          <p:cNvPr id="10" name="TextBox 9"/>
+          <p:cNvSpPr txBox="1"/>
+          <p:nvPr/>
+        </p:nvSpPr>
+        <p:spPr>
+          <a:xfrm>
+            <a:off x="932688" y="1993392"/>
             <a:ext cx="1234440" cy="201168"/>
           </a:xfrm>
           <a:prstGeom prst="rect">
@@ -12493,20 +12897,20 @@
                 </a:solidFill>
                 <a:latin typeface="PingFang SC"/>
               </a:rPr>
-              <a:t>Web Assistant</a:t>
-            </a:r>
-          </a:p>
-        </p:txBody>
-      </p:sp>
-      <p:sp>
-        <p:nvSpPr>
-          <p:cNvPr id="27" name="TextBox 26"/>
-          <p:cNvSpPr txBox="1"/>
-          <p:nvPr/>
-        </p:nvSpPr>
-        <p:spPr>
-          <a:xfrm>
-            <a:off x="5751576" y="3017520"/>
+              <a:t>Before</a:t>
+            </a:r>
+          </a:p>
+        </p:txBody>
+      </p:sp>
+      <p:sp>
+        <p:nvSpPr>
+          <p:cNvPr id="11" name="TextBox 10"/>
+          <p:cNvSpPr txBox="1"/>
+          <p:nvPr/>
+        </p:nvSpPr>
+        <p:spPr>
+          <a:xfrm>
+            <a:off x="2066543" y="1965960"/>
             <a:ext cx="960120" cy="274320"/>
           </a:xfrm>
           <a:prstGeom prst="rect">
@@ -12531,24 +12935,24 @@
             <a:r>
               <a:rPr sz="1400" b="1">
                 <a:solidFill>
-                  <a:srgbClr val="17745A"/>
+                  <a:srgbClr val="C84438"/>
                 </a:solidFill>
                 <a:latin typeface="Helvetica Neue"/>
               </a:rPr>
-              <a:t>3 / 3</a:t>
-            </a:r>
-          </a:p>
-        </p:txBody>
-      </p:sp>
-      <p:sp>
-        <p:nvSpPr>
-          <p:cNvPr id="28" name="TextBox 27"/>
-          <p:cNvSpPr txBox="1"/>
-          <p:nvPr/>
-        </p:nvSpPr>
-        <p:spPr>
-          <a:xfrm>
-            <a:off x="6638544" y="3054096"/>
+              <a:t>2 / 5</a:t>
+            </a:r>
+          </a:p>
+        </p:txBody>
+      </p:sp>
+      <p:sp>
+        <p:nvSpPr>
+          <p:cNvPr id="12" name="TextBox 11"/>
+          <p:cNvSpPr txBox="1"/>
+          <p:nvPr/>
+        </p:nvSpPr>
+        <p:spPr>
+          <a:xfrm>
+            <a:off x="2953512" y="2002536"/>
             <a:ext cx="914400" cy="256032"/>
           </a:xfrm>
           <a:prstGeom prst="rect">
@@ -12577,20 +12981,20 @@
                 </a:solidFill>
                 <a:latin typeface="PingFang SC"/>
               </a:rPr>
-              <a:t>确认与提交分离</a:t>
-            </a:r>
-          </a:p>
-        </p:txBody>
-      </p:sp>
-      <p:sp>
-        <p:nvSpPr>
-          <p:cNvPr id="29" name="Rectangle 28"/>
+              <a:t>3 次行为失败</a:t>
+            </a:r>
+          </a:p>
+        </p:txBody>
+      </p:sp>
+      <p:sp>
+        <p:nvSpPr>
+          <p:cNvPr id="13" name="Rectangle 12"/>
           <p:cNvSpPr/>
           <p:nvPr/>
         </p:nvSpPr>
         <p:spPr>
           <a:xfrm>
-            <a:off x="8083296" y="2898648"/>
+            <a:off x="4398264" y="1847088"/>
             <a:ext cx="3364992" cy="841248"/>
           </a:xfrm>
           <a:prstGeom prst="rect">
@@ -12629,6 +13033,690 @@
       </p:sp>
       <p:sp>
         <p:nvSpPr>
+          <p:cNvPr id="14" name="TextBox 13"/>
+          <p:cNvSpPr txBox="1"/>
+          <p:nvPr/>
+        </p:nvSpPr>
+        <p:spPr>
+          <a:xfrm>
+            <a:off x="4617720" y="1993392"/>
+            <a:ext cx="1234440" cy="201168"/>
+          </a:xfrm>
+          <a:prstGeom prst="rect">
+            <a:avLst/>
+          </a:prstGeom>
+          <a:noFill/>
+        </p:spPr>
+        <p:txBody>
+          <a:bodyPr wrap="square" lIns="0" rIns="0" tIns="0" bIns="0" anchor="t">
+            <a:spAutoFit/>
+          </a:bodyPr>
+          <a:lstStyle/>
+          <a:p>
+            <a:pPr algn="l">
+              <a:lnSpc>
+                <a:spcPct val="108000"/>
+              </a:lnSpc>
+              <a:spcAft>
+                <a:spcPts val="0"/>
+              </a:spcAft>
+            </a:pPr>
+            <a:r>
+              <a:rPr sz="950" b="1">
+                <a:solidFill>
+                  <a:srgbClr val="67706B"/>
+                </a:solidFill>
+                <a:latin typeface="PingFang SC"/>
+              </a:rPr>
+              <a:t>Headline</a:t>
+            </a:r>
+          </a:p>
+        </p:txBody>
+      </p:sp>
+      <p:sp>
+        <p:nvSpPr>
+          <p:cNvPr id="15" name="TextBox 14"/>
+          <p:cNvSpPr txBox="1"/>
+          <p:nvPr/>
+        </p:nvSpPr>
+        <p:spPr>
+          <a:xfrm>
+            <a:off x="5751576" y="1965960"/>
+            <a:ext cx="960120" cy="274320"/>
+          </a:xfrm>
+          <a:prstGeom prst="rect">
+            <a:avLst/>
+          </a:prstGeom>
+          <a:noFill/>
+        </p:spPr>
+        <p:txBody>
+          <a:bodyPr wrap="square" lIns="0" rIns="0" tIns="0" bIns="0" anchor="t">
+            <a:spAutoFit/>
+          </a:bodyPr>
+          <a:lstStyle/>
+          <a:p>
+            <a:pPr algn="l">
+              <a:lnSpc>
+                <a:spcPct val="108000"/>
+              </a:lnSpc>
+              <a:spcAft>
+                <a:spcPts val="0"/>
+              </a:spcAft>
+            </a:pPr>
+            <a:r>
+              <a:rPr sz="1400" b="1">
+                <a:solidFill>
+                  <a:srgbClr val="17745A"/>
+                </a:solidFill>
+                <a:latin typeface="Helvetica Neue"/>
+              </a:rPr>
+              <a:t>5 / 5</a:t>
+            </a:r>
+          </a:p>
+        </p:txBody>
+      </p:sp>
+      <p:sp>
+        <p:nvSpPr>
+          <p:cNvPr id="16" name="TextBox 15"/>
+          <p:cNvSpPr txBox="1"/>
+          <p:nvPr/>
+        </p:nvSpPr>
+        <p:spPr>
+          <a:xfrm>
+            <a:off x="6638544" y="2002536"/>
+            <a:ext cx="914400" cy="256032"/>
+          </a:xfrm>
+          <a:prstGeom prst="rect">
+            <a:avLst/>
+          </a:prstGeom>
+          <a:noFill/>
+        </p:spPr>
+        <p:txBody>
+          <a:bodyPr wrap="square" lIns="0" rIns="0" tIns="0" bIns="0" anchor="t">
+            <a:spAutoFit/>
+          </a:bodyPr>
+          <a:lstStyle/>
+          <a:p>
+            <a:pPr algn="l">
+              <a:lnSpc>
+                <a:spcPct val="108000"/>
+              </a:lnSpc>
+              <a:spcAft>
+                <a:spcPts val="0"/>
+              </a:spcAft>
+            </a:pPr>
+            <a:r>
+              <a:rPr sz="860" b="0">
+                <a:solidFill>
+                  <a:srgbClr val="67706B"/>
+                </a:solidFill>
+                <a:latin typeface="PingFang SC"/>
+              </a:rPr>
+              <a:t>同 Case + Manifest</a:t>
+            </a:r>
+          </a:p>
+        </p:txBody>
+      </p:sp>
+      <p:sp>
+        <p:nvSpPr>
+          <p:cNvPr id="17" name="Rectangle 16"/>
+          <p:cNvSpPr/>
+          <p:nvPr/>
+        </p:nvSpPr>
+        <p:spPr>
+          <a:xfrm>
+            <a:off x="8083296" y="1847088"/>
+            <a:ext cx="3364992" cy="841248"/>
+          </a:xfrm>
+          <a:prstGeom prst="rect">
+            <a:avLst/>
+          </a:prstGeom>
+          <a:solidFill>
+            <a:srgbClr val="FFFFFF"/>
+          </a:solidFill>
+          <a:ln w="8890">
+            <a:solidFill>
+              <a:srgbClr val="D8DDD9"/>
+            </a:solidFill>
+          </a:ln>
+        </p:spPr>
+        <p:style>
+          <a:lnRef idx="1">
+            <a:schemeClr val="accent1"/>
+          </a:lnRef>
+          <a:fillRef idx="3">
+            <a:schemeClr val="accent1"/>
+          </a:fillRef>
+          <a:effectRef idx="2">
+            <a:schemeClr val="accent1"/>
+          </a:effectRef>
+          <a:fontRef idx="minor">
+            <a:schemeClr val="lt1"/>
+          </a:fontRef>
+        </p:style>
+        <p:txBody>
+          <a:bodyPr rtlCol="0" anchor="ctr"/>
+          <a:lstStyle/>
+          <a:p>
+            <a:pPr algn="ctr"/>
+          </a:p>
+        </p:txBody>
+      </p:sp>
+      <p:sp>
+        <p:nvSpPr>
+          <p:cNvPr id="18" name="TextBox 17"/>
+          <p:cNvSpPr txBox="1"/>
+          <p:nvPr/>
+        </p:nvSpPr>
+        <p:spPr>
+          <a:xfrm>
+            <a:off x="8302752" y="1993392"/>
+            <a:ext cx="1234440" cy="201168"/>
+          </a:xfrm>
+          <a:prstGeom prst="rect">
+            <a:avLst/>
+          </a:prstGeom>
+          <a:noFill/>
+        </p:spPr>
+        <p:txBody>
+          <a:bodyPr wrap="square" lIns="0" rIns="0" tIns="0" bIns="0" anchor="t">
+            <a:spAutoFit/>
+          </a:bodyPr>
+          <a:lstStyle/>
+          <a:p>
+            <a:pPr algn="l">
+              <a:lnSpc>
+                <a:spcPct val="108000"/>
+              </a:lnSpc>
+              <a:spcAft>
+                <a:spcPts val="0"/>
+              </a:spcAft>
+            </a:pPr>
+            <a:r>
+              <a:rPr sz="950" b="1">
+                <a:solidFill>
+                  <a:srgbClr val="67706B"/>
+                </a:solidFill>
+                <a:latin typeface="PingFang SC"/>
+              </a:rPr>
+              <a:t>Matrix</a:t>
+            </a:r>
+          </a:p>
+        </p:txBody>
+      </p:sp>
+      <p:sp>
+        <p:nvSpPr>
+          <p:cNvPr id="19" name="TextBox 18"/>
+          <p:cNvSpPr txBox="1"/>
+          <p:nvPr/>
+        </p:nvSpPr>
+        <p:spPr>
+          <a:xfrm>
+            <a:off x="9436608" y="1965960"/>
+            <a:ext cx="960120" cy="274320"/>
+          </a:xfrm>
+          <a:prstGeom prst="rect">
+            <a:avLst/>
+          </a:prstGeom>
+          <a:noFill/>
+        </p:spPr>
+        <p:txBody>
+          <a:bodyPr wrap="square" lIns="0" rIns="0" tIns="0" bIns="0" anchor="t">
+            <a:spAutoFit/>
+          </a:bodyPr>
+          <a:lstStyle/>
+          <a:p>
+            <a:pPr algn="l">
+              <a:lnSpc>
+                <a:spcPct val="108000"/>
+              </a:lnSpc>
+              <a:spcAft>
+                <a:spcPts val="0"/>
+              </a:spcAft>
+            </a:pPr>
+            <a:r>
+              <a:rPr sz="1400" b="1">
+                <a:solidFill>
+                  <a:srgbClr val="17745A"/>
+                </a:solidFill>
+                <a:latin typeface="Helvetica Neue"/>
+              </a:rPr>
+              <a:t>30 / 30</a:t>
+            </a:r>
+          </a:p>
+        </p:txBody>
+      </p:sp>
+      <p:sp>
+        <p:nvSpPr>
+          <p:cNvPr id="20" name="TextBox 19"/>
+          <p:cNvSpPr txBox="1"/>
+          <p:nvPr/>
+        </p:nvSpPr>
+        <p:spPr>
+          <a:xfrm>
+            <a:off x="10323576" y="2002536"/>
+            <a:ext cx="914400" cy="256032"/>
+          </a:xfrm>
+          <a:prstGeom prst="rect">
+            <a:avLst/>
+          </a:prstGeom>
+          <a:noFill/>
+        </p:spPr>
+        <p:txBody>
+          <a:bodyPr wrap="square" lIns="0" rIns="0" tIns="0" bIns="0" anchor="t">
+            <a:spAutoFit/>
+          </a:bodyPr>
+          <a:lstStyle/>
+          <a:p>
+            <a:pPr algn="l">
+              <a:lnSpc>
+                <a:spcPct val="108000"/>
+              </a:lnSpc>
+              <a:spcAft>
+                <a:spcPts val="0"/>
+              </a:spcAft>
+            </a:pPr>
+            <a:r>
+              <a:rPr sz="860" b="0">
+                <a:solidFill>
+                  <a:srgbClr val="67706B"/>
+                </a:solidFill>
+                <a:latin typeface="PingFang SC"/>
+              </a:rPr>
+              <a:t>6 Cells</a:t>
+            </a:r>
+          </a:p>
+        </p:txBody>
+      </p:sp>
+      <p:sp>
+        <p:nvSpPr>
+          <p:cNvPr id="21" name="Rectangle 20"/>
+          <p:cNvSpPr/>
+          <p:nvPr/>
+        </p:nvSpPr>
+        <p:spPr>
+          <a:xfrm>
+            <a:off x="713232" y="2898648"/>
+            <a:ext cx="3364992" cy="841248"/>
+          </a:xfrm>
+          <a:prstGeom prst="rect">
+            <a:avLst/>
+          </a:prstGeom>
+          <a:solidFill>
+            <a:srgbClr val="FFFFFF"/>
+          </a:solidFill>
+          <a:ln w="8890">
+            <a:solidFill>
+              <a:srgbClr val="D8DDD9"/>
+            </a:solidFill>
+          </a:ln>
+        </p:spPr>
+        <p:style>
+          <a:lnRef idx="1">
+            <a:schemeClr val="accent1"/>
+          </a:lnRef>
+          <a:fillRef idx="3">
+            <a:schemeClr val="accent1"/>
+          </a:fillRef>
+          <a:effectRef idx="2">
+            <a:schemeClr val="accent1"/>
+          </a:effectRef>
+          <a:fontRef idx="minor">
+            <a:schemeClr val="lt1"/>
+          </a:fontRef>
+        </p:style>
+        <p:txBody>
+          <a:bodyPr rtlCol="0" anchor="ctr"/>
+          <a:lstStyle/>
+          <a:p>
+            <a:pPr algn="ctr"/>
+          </a:p>
+        </p:txBody>
+      </p:sp>
+      <p:sp>
+        <p:nvSpPr>
+          <p:cNvPr id="22" name="TextBox 21"/>
+          <p:cNvSpPr txBox="1"/>
+          <p:nvPr/>
+        </p:nvSpPr>
+        <p:spPr>
+          <a:xfrm>
+            <a:off x="932688" y="3044952"/>
+            <a:ext cx="1234440" cy="201168"/>
+          </a:xfrm>
+          <a:prstGeom prst="rect">
+            <a:avLst/>
+          </a:prstGeom>
+          <a:noFill/>
+        </p:spPr>
+        <p:txBody>
+          <a:bodyPr wrap="square" lIns="0" rIns="0" tIns="0" bIns="0" anchor="t">
+            <a:spAutoFit/>
+          </a:bodyPr>
+          <a:lstStyle/>
+          <a:p>
+            <a:pPr algn="l">
+              <a:lnSpc>
+                <a:spcPct val="108000"/>
+              </a:lnSpc>
+              <a:spcAft>
+                <a:spcPts val="0"/>
+              </a:spcAft>
+            </a:pPr>
+            <a:r>
+              <a:rPr sz="950" b="1">
+                <a:solidFill>
+                  <a:srgbClr val="67706B"/>
+                </a:solidFill>
+                <a:latin typeface="PingFang SC"/>
+              </a:rPr>
+              <a:t>Sample replay</a:t>
+            </a:r>
+          </a:p>
+        </p:txBody>
+      </p:sp>
+      <p:sp>
+        <p:nvSpPr>
+          <p:cNvPr id="23" name="TextBox 22"/>
+          <p:cNvSpPr txBox="1"/>
+          <p:nvPr/>
+        </p:nvSpPr>
+        <p:spPr>
+          <a:xfrm>
+            <a:off x="2066543" y="3017520"/>
+            <a:ext cx="960120" cy="274320"/>
+          </a:xfrm>
+          <a:prstGeom prst="rect">
+            <a:avLst/>
+          </a:prstGeom>
+          <a:noFill/>
+        </p:spPr>
+        <p:txBody>
+          <a:bodyPr wrap="square" lIns="0" rIns="0" tIns="0" bIns="0" anchor="t">
+            <a:spAutoFit/>
+          </a:bodyPr>
+          <a:lstStyle/>
+          <a:p>
+            <a:pPr algn="l">
+              <a:lnSpc>
+                <a:spcPct val="108000"/>
+              </a:lnSpc>
+              <a:spcAft>
+                <a:spcPts val="0"/>
+              </a:spcAft>
+            </a:pPr>
+            <a:r>
+              <a:rPr sz="1400" b="1">
+                <a:solidFill>
+                  <a:srgbClr val="17745A"/>
+                </a:solidFill>
+                <a:latin typeface="Helvetica Neue"/>
+              </a:rPr>
+              <a:t>5 / 5</a:t>
+            </a:r>
+          </a:p>
+        </p:txBody>
+      </p:sp>
+      <p:sp>
+        <p:nvSpPr>
+          <p:cNvPr id="24" name="TextBox 23"/>
+          <p:cNvSpPr txBox="1"/>
+          <p:nvPr/>
+        </p:nvSpPr>
+        <p:spPr>
+          <a:xfrm>
+            <a:off x="2953512" y="3054096"/>
+            <a:ext cx="914400" cy="256032"/>
+          </a:xfrm>
+          <a:prstGeom prst="rect">
+            <a:avLst/>
+          </a:prstGeom>
+          <a:noFill/>
+        </p:spPr>
+        <p:txBody>
+          <a:bodyPr wrap="square" lIns="0" rIns="0" tIns="0" bIns="0" anchor="t">
+            <a:spAutoFit/>
+          </a:bodyPr>
+          <a:lstStyle/>
+          <a:p>
+            <a:pPr algn="l">
+              <a:lnSpc>
+                <a:spcPct val="108000"/>
+              </a:lnSpc>
+              <a:spcAft>
+                <a:spcPts val="0"/>
+              </a:spcAft>
+            </a:pPr>
+            <a:r>
+              <a:rPr sz="860" b="0">
+                <a:solidFill>
+                  <a:srgbClr val="67706B"/>
+                </a:solidFill>
+                <a:latin typeface="PingFang SC"/>
+              </a:rPr>
+              <a:t>0 real_tool</a:t>
+            </a:r>
+          </a:p>
+        </p:txBody>
+      </p:sp>
+      <p:sp>
+        <p:nvSpPr>
+          <p:cNvPr id="25" name="Rectangle 24"/>
+          <p:cNvSpPr/>
+          <p:nvPr/>
+        </p:nvSpPr>
+        <p:spPr>
+          <a:xfrm>
+            <a:off x="4398264" y="2898648"/>
+            <a:ext cx="3364992" cy="841248"/>
+          </a:xfrm>
+          <a:prstGeom prst="rect">
+            <a:avLst/>
+          </a:prstGeom>
+          <a:solidFill>
+            <a:srgbClr val="FFFFFF"/>
+          </a:solidFill>
+          <a:ln w="8890">
+            <a:solidFill>
+              <a:srgbClr val="D8DDD9"/>
+            </a:solidFill>
+          </a:ln>
+        </p:spPr>
+        <p:style>
+          <a:lnRef idx="1">
+            <a:schemeClr val="accent1"/>
+          </a:lnRef>
+          <a:fillRef idx="3">
+            <a:schemeClr val="accent1"/>
+          </a:fillRef>
+          <a:effectRef idx="2">
+            <a:schemeClr val="accent1"/>
+          </a:effectRef>
+          <a:fontRef idx="minor">
+            <a:schemeClr val="lt1"/>
+          </a:fontRef>
+        </p:style>
+        <p:txBody>
+          <a:bodyPr rtlCol="0" anchor="ctr"/>
+          <a:lstStyle/>
+          <a:p>
+            <a:pPr algn="ctr"/>
+          </a:p>
+        </p:txBody>
+      </p:sp>
+      <p:sp>
+        <p:nvSpPr>
+          <p:cNvPr id="26" name="TextBox 25"/>
+          <p:cNvSpPr txBox="1"/>
+          <p:nvPr/>
+        </p:nvSpPr>
+        <p:spPr>
+          <a:xfrm>
+            <a:off x="4617720" y="3044952"/>
+            <a:ext cx="1234440" cy="201168"/>
+          </a:xfrm>
+          <a:prstGeom prst="rect">
+            <a:avLst/>
+          </a:prstGeom>
+          <a:noFill/>
+        </p:spPr>
+        <p:txBody>
+          <a:bodyPr wrap="square" lIns="0" rIns="0" tIns="0" bIns="0" anchor="t">
+            <a:spAutoFit/>
+          </a:bodyPr>
+          <a:lstStyle/>
+          <a:p>
+            <a:pPr algn="l">
+              <a:lnSpc>
+                <a:spcPct val="108000"/>
+              </a:lnSpc>
+              <a:spcAft>
+                <a:spcPts val="0"/>
+              </a:spcAft>
+            </a:pPr>
+            <a:r>
+              <a:rPr sz="950" b="1">
+                <a:solidFill>
+                  <a:srgbClr val="67706B"/>
+                </a:solidFill>
+                <a:latin typeface="PingFang SC"/>
+              </a:rPr>
+              <a:t>Web Assistant</a:t>
+            </a:r>
+          </a:p>
+        </p:txBody>
+      </p:sp>
+      <p:sp>
+        <p:nvSpPr>
+          <p:cNvPr id="27" name="TextBox 26"/>
+          <p:cNvSpPr txBox="1"/>
+          <p:nvPr/>
+        </p:nvSpPr>
+        <p:spPr>
+          <a:xfrm>
+            <a:off x="5751576" y="3017520"/>
+            <a:ext cx="960120" cy="274320"/>
+          </a:xfrm>
+          <a:prstGeom prst="rect">
+            <a:avLst/>
+          </a:prstGeom>
+          <a:noFill/>
+        </p:spPr>
+        <p:txBody>
+          <a:bodyPr wrap="square" lIns="0" rIns="0" tIns="0" bIns="0" anchor="t">
+            <a:spAutoFit/>
+          </a:bodyPr>
+          <a:lstStyle/>
+          <a:p>
+            <a:pPr algn="l">
+              <a:lnSpc>
+                <a:spcPct val="108000"/>
+              </a:lnSpc>
+              <a:spcAft>
+                <a:spcPts val="0"/>
+              </a:spcAft>
+            </a:pPr>
+            <a:r>
+              <a:rPr sz="1400" b="1">
+                <a:solidFill>
+                  <a:srgbClr val="17745A"/>
+                </a:solidFill>
+                <a:latin typeface="Helvetica Neue"/>
+              </a:rPr>
+              <a:t>3 / 3</a:t>
+            </a:r>
+          </a:p>
+        </p:txBody>
+      </p:sp>
+      <p:sp>
+        <p:nvSpPr>
+          <p:cNvPr id="28" name="TextBox 27"/>
+          <p:cNvSpPr txBox="1"/>
+          <p:nvPr/>
+        </p:nvSpPr>
+        <p:spPr>
+          <a:xfrm>
+            <a:off x="6638544" y="3054096"/>
+            <a:ext cx="914400" cy="256032"/>
+          </a:xfrm>
+          <a:prstGeom prst="rect">
+            <a:avLst/>
+          </a:prstGeom>
+          <a:noFill/>
+        </p:spPr>
+        <p:txBody>
+          <a:bodyPr wrap="square" lIns="0" rIns="0" tIns="0" bIns="0" anchor="t">
+            <a:spAutoFit/>
+          </a:bodyPr>
+          <a:lstStyle/>
+          <a:p>
+            <a:pPr algn="l">
+              <a:lnSpc>
+                <a:spcPct val="108000"/>
+              </a:lnSpc>
+              <a:spcAft>
+                <a:spcPts val="0"/>
+              </a:spcAft>
+            </a:pPr>
+            <a:r>
+              <a:rPr sz="860" b="0">
+                <a:solidFill>
+                  <a:srgbClr val="67706B"/>
+                </a:solidFill>
+                <a:latin typeface="PingFang SC"/>
+              </a:rPr>
+              <a:t>确认与提交分离</a:t>
+            </a:r>
+          </a:p>
+        </p:txBody>
+      </p:sp>
+      <p:sp>
+        <p:nvSpPr>
+          <p:cNvPr id="29" name="Rectangle 28"/>
+          <p:cNvSpPr/>
+          <p:nvPr/>
+        </p:nvSpPr>
+        <p:spPr>
+          <a:xfrm>
+            <a:off x="8083296" y="2898648"/>
+            <a:ext cx="3364992" cy="841248"/>
+          </a:xfrm>
+          <a:prstGeom prst="rect">
+            <a:avLst/>
+          </a:prstGeom>
+          <a:solidFill>
+            <a:srgbClr val="FFFFFF"/>
+          </a:solidFill>
+          <a:ln w="8890">
+            <a:solidFill>
+              <a:srgbClr val="D8DDD9"/>
+            </a:solidFill>
+          </a:ln>
+        </p:spPr>
+        <p:style>
+          <a:lnRef idx="1">
+            <a:schemeClr val="accent1"/>
+          </a:lnRef>
+          <a:fillRef idx="3">
+            <a:schemeClr val="accent1"/>
+          </a:fillRef>
+          <a:effectRef idx="2">
+            <a:schemeClr val="accent1"/>
+          </a:effectRef>
+          <a:fontRef idx="minor">
+            <a:schemeClr val="lt1"/>
+          </a:fontRef>
+        </p:style>
+        <p:txBody>
+          <a:bodyPr rtlCol="0" anchor="ctr"/>
+          <a:lstStyle/>
+          <a:p>
+            <a:pPr algn="ctr"/>
+          </a:p>
+        </p:txBody>
+      </p:sp>
+      <p:sp>
+        <p:nvSpPr>
           <p:cNvPr id="30" name="TextBox 29"/>
           <p:cNvSpPr txBox="1"/>
           <p:nvPr/>
@@ -12875,7 +13963,7 @@
                 </a:solidFill>
                 <a:latin typeface="PingFang SC"/>
               </a:rPr>
-              <a:t>Sample 仅覆盖 inspect_image；动态引用等值以 Timeline 展示；正式录制必须生成新 ID；</a:t>
+              <a:t>Sample 仅覆盖 inspect_image；动态引用等值以 Timeline 展示；全部 ID 来自干净录制库；</a:t>
             </a:r>
           </a:p>
           <a:p>
@@ -13300,7 +14388,7 @@
                 </a:solidFill>
                 <a:latin typeface="Helvetica Neue"/>
               </a:rPr>
-              <a:t>02 / 16</a:t>
+              <a:t>02 / 18</a:t>
             </a:r>
           </a:p>
         </p:txBody>
@@ -14657,7 +15745,7 @@
                 </a:solidFill>
                 <a:latin typeface="Helvetica Neue"/>
               </a:rPr>
-              <a:t>03 / 16</a:t>
+              <a:t>03 / 18</a:t>
             </a:r>
           </a:p>
         </p:txBody>
@@ -15903,7 +16991,7 @@
                 </a:solidFill>
                 <a:latin typeface="Helvetica Neue"/>
               </a:rPr>
-              <a:t>04 / 16</a:t>
+              <a:t>04 / 18</a:t>
             </a:r>
           </a:p>
         </p:txBody>
@@ -18030,7 +19118,7 @@
                 </a:solidFill>
                 <a:latin typeface="Helvetica Neue"/>
               </a:rPr>
-              <a:t>05 / 16</a:t>
+              <a:t>05 / 18</a:t>
             </a:r>
           </a:p>
         </p:txBody>
@@ -18944,7 +20032,7 @@
                 </a:solidFill>
                 <a:latin typeface="Helvetica Neue"/>
               </a:rPr>
-              <a:t>06 / 16</a:t>
+              <a:t>06 / 18</a:t>
             </a:r>
           </a:p>
         </p:txBody>
@@ -20721,7 +21809,7 @@
                 </a:solidFill>
                 <a:latin typeface="Helvetica Neue"/>
               </a:rPr>
-              <a:t>07 / 16</a:t>
+              <a:t>07 / 18</a:t>
             </a:r>
           </a:p>
         </p:txBody>
@@ -21839,7 +22927,7 @@
                 </a:solidFill>
                 <a:latin typeface="Helvetica Neue"/>
               </a:rPr>
-              <a:t>08 / 16</a:t>
+              <a:t>08 / 18</a:t>
             </a:r>
           </a:p>
         </p:txBody>
@@ -23609,7 +24697,7 @@
                 </a:solidFill>
                 <a:latin typeface="Helvetica Neue"/>
               </a:rPr>
-              <a:t>09 / 16</a:t>
+              <a:t>09 / 18</a:t>
             </a:r>
           </a:p>
         </p:txBody>

</xml_diff>

<commit_message>
feat: feature the sanitized internal evaluation platform on slide 16
Co-Authored-By: Claude Fable 5 <noreply@anthropic.com>
</commit_message>
<xml_diff>
--- a/docs/competition/AgentRig-GOAI-2026-初赛方案.pptx
+++ b/docs/competition/AgentRig-GOAI-2026-初赛方案.pptx
@@ -11849,7 +11849,7 @@
         <p:spPr>
           <a:xfrm>
             <a:off x="7406640" y="1810512"/>
-            <a:ext cx="4078224" cy="2276856"/>
+            <a:ext cx="4078224" cy="2130552"/>
           </a:xfrm>
           <a:prstGeom prst="rect">
             <a:avLst/>
@@ -11887,7 +11887,7 @@
       </p:sp>
       <p:pic>
         <p:nvPicPr>
-          <p:cNvPr id="13" name="Picture 12" descr="prod-live-02-regression.png"/>
+          <p:cNvPr id="13" name="Picture 12" descr="prod-platform-batches.png"/>
           <p:cNvPicPr>
             <a:picLocks noChangeAspect="1"/>
           </p:cNvPicPr>
@@ -11902,7 +11902,7 @@
         <p:spPr>
           <a:xfrm>
             <a:off x="7424927" y="1828800"/>
-            <a:ext cx="4041648" cy="2240280"/>
+            <a:ext cx="4041648" cy="2093976"/>
           </a:xfrm>
           <a:prstGeom prst="rect">
             <a:avLst/>
@@ -11986,7 +11986,7 @@
         </p:nvSpPr>
         <p:spPr>
           <a:xfrm>
-            <a:off x="7424927" y="4078224"/>
+            <a:off x="7424927" y="4005072"/>
             <a:ext cx="4041648" cy="182880"/>
           </a:xfrm>
           <a:prstGeom prst="rect">
@@ -12015,7 +12015,7 @@
                 </a:solidFill>
                 <a:latin typeface="PingFang SC"/>
               </a:rPr>
-              <a:t>哨兵异常 → 归因 → 修用例/修输入</a:t>
+              <a:t>内部评测平台:30 个批次任务,LIVE API 常态运行</a:t>
             </a:r>
           </a:p>
         </p:txBody>

</xml_diff>